<commit_message>
Add Thein Kyaw Lwin's multi-task experiment to Group 3 assignment 7
Compare his runs with the group baseline on his split, and update the README and slides with the findings.
</commit_message>
<xml_diff>
--- a/assignment/assignment-7/Group-3/myPolar_Assignment7_G3.pptx
+++ b/assignment/assignment-7/Group-3/myPolar_Assignment7_G3.pptx
@@ -13,6 +13,8 @@
     <p:sldId id="261" r:id="rId7"/>
     <p:sldId id="262" r:id="rId8"/>
     <p:sldId id="263" r:id="rId9"/>
+    <p:sldId id="270" r:id="rId21"/>
+    <p:sldId id="271" r:id="rId22"/>
     <p:sldId id="264" r:id="rId10"/>
     <p:sldId id="265" r:id="rId11"/>
     <p:sldId id="266" r:id="rId12"/>
@@ -1842,7 +1844,7 @@
           <a:p>
             <a:r>
               <a:rPr lang="en-US" dirty="0"/>
-              <a:t>အနှစ်ချုပ်ပါ။ Data နည်းတော့ TF-IDF က အားကောင်းပါတယ်။ ဒါပေမဲ့ random split score က contributor effect ကြောင့် မြင့်နေတာပါ။ Unseen contributor မှာ neural model တွေက ပိုခံနိုင်ပါတယ်။ Explicit label တွေက လွယ်ပြီး implicit label တွေက ခက်ပါတယ်။ 0.01–0.02 ကွာတာက noise အတွင်းမှာပါ။</a:t>
+              <a:t>အနှစ်ချုပ်ပါ။ Data နည်းတော့ TF-IDF က အားကောင်းပါတယ်။ ဒါပေမဲ့ random split score က contributor effect ကြောင့် မြင့်နေတာပါ။ Unseen contributor မှာ neural model တွေက ပိုခံနိုင်ပါတယ်။ Explicit label တွေက လွယ်ပြီး implicit label တွေက ခက်ပါတယ်။ 0.01–0.04 ကွာတာက noise အတွင်းမှာပါ၊ split ပြောင်းရင် ranking ပြောင်းပါတယ်။</a:t>
             </a:r>
             <a:endParaRPr lang="en-US" dirty="0"/>
           </a:p>
@@ -1972,6 +1974,182 @@
 </p:notes>
 </file>
 
+<file path=ppt/notesSlides/notesSlide15.xml><?xml version="1.0" encoding="utf-8"?>
+<p:notes xmlns:a="http://schemas.openxmlformats.org/drawingml/2006/main" xmlns:r="http://schemas.openxmlformats.org/officeDocument/2006/relationships" xmlns:p="http://schemas.openxmlformats.org/presentationml/2006/main">
+  <p:cSld>
+    <p:spTree>
+      <p:nvGrpSpPr>
+        <p:cNvPr id="1" name=""/>
+        <p:cNvGrpSpPr/>
+        <p:nvPr/>
+      </p:nvGrpSpPr>
+      <p:grpSpPr>
+        <a:xfrm>
+          <a:off x="0" y="0"/>
+          <a:ext cx="0" cy="0"/>
+          <a:chOff x="0" y="0"/>
+          <a:chExt cx="0" cy="0"/>
+        </a:xfrm>
+      </p:grpSpPr>
+      <p:sp>
+        <p:nvSpPr>
+          <p:cNvPr id="2" name="Slide Image Placeholder 1"/>
+          <p:cNvSpPr>
+            <a:spLocks noGrp="1" noRot="1" noChangeAspect="1"/>
+          </p:cNvSpPr>
+          <p:nvPr>
+            <p:ph type="sldImg"/>
+          </p:nvPr>
+        </p:nvSpPr>
+        <p:spPr/>
+      </p:sp>
+      <p:sp>
+        <p:nvSpPr>
+          <p:cNvPr id="3" name="Notes Placeholder 2"/>
+          <p:cNvSpPr>
+            <a:spLocks noGrp="1"/>
+          </p:cNvSpPr>
+          <p:nvPr>
+            <p:ph type="body" idx="1"/>
+          </p:nvPr>
+        </p:nvSpPr>
+        <p:spPr/>
+        <p:txBody>
+          <a:bodyPr/>
+          <a:lstStyle/>
+          <a:p>
+            <a:r>
+              <a:rPr lang="en-US" dirty="0"/>
+              <a:t>Thein Kyaw Lwin က final_dataset.csv တစ်ခုတည်းကို သုံးပြီး သီးခြား experiment တစ်ခု လုပ်ထားပါတယ်။ Model တစ်ခုတည်းက Task သုံးခုလုံးကို တပြိုင်နက် ခန့်မှန်းပါတယ်။ Cleaning၊ segmentation နဲ့ split မတူတဲ့အတွက် သူ့ test sentence တစ်ဝက်လောက်က အဖွဲ့ရဲ့ training split ထဲမှာ ရှိနေပါတယ်။ ဒါကြောင့် score တွေကို တိုက်ရိုက် နှိုင်းယှဉ်လို့ မရပါဘူး။</a:t>
+            </a:r>
+            <a:endParaRPr lang="en-US" dirty="0"/>
+          </a:p>
+        </p:txBody>
+      </p:sp>
+      <p:sp>
+        <p:nvSpPr>
+          <p:cNvPr id="4" name="Slide Number Placeholder 3"/>
+          <p:cNvSpPr>
+            <a:spLocks noGrp="1"/>
+          </p:cNvSpPr>
+          <p:nvPr>
+            <p:ph type="sldNum" sz="quarter" idx="10"/>
+          </p:nvPr>
+        </p:nvSpPr>
+        <p:spPr/>
+        <p:txBody>
+          <a:bodyPr/>
+          <a:lstStyle/>
+          <a:p>
+            <a:fld id="{F7021451-1387-4CA6-816F-3879F97B5CBC}" type="slidenum">
+              <a:rPr lang="en-US"/>
+              <a:t>15</a:t>
+            </a:fld>
+            <a:endParaRPr lang="en-US"/>
+          </a:p>
+        </p:txBody>
+      </p:sp>
+    </p:spTree>
+    <p:extLst>
+      <p:ext uri="{BB962C8B-B14F-4D97-AF65-F5344CB8AC3E}">
+        <p14:creationId xmlns:p14="http://schemas.microsoft.com/office/powerpoint/2010/main" val="1024087015"/>
+      </p:ext>
+    </p:extLst>
+  </p:cSld>
+  <p:clrMapOvr>
+    <a:masterClrMapping/>
+  </p:clrMapOvr>
+</p:notes>
+</file>
+
+<file path=ppt/notesSlides/notesSlide16.xml><?xml version="1.0" encoding="utf-8"?>
+<p:notes xmlns:a="http://schemas.openxmlformats.org/drawingml/2006/main" xmlns:r="http://schemas.openxmlformats.org/officeDocument/2006/relationships" xmlns:p="http://schemas.openxmlformats.org/presentationml/2006/main">
+  <p:cSld>
+    <p:spTree>
+      <p:nvGrpSpPr>
+        <p:cNvPr id="1" name=""/>
+        <p:cNvGrpSpPr/>
+        <p:nvPr/>
+      </p:nvGrpSpPr>
+      <p:grpSpPr>
+        <a:xfrm>
+          <a:off x="0" y="0"/>
+          <a:ext cx="0" cy="0"/>
+          <a:chOff x="0" y="0"/>
+          <a:chExt cx="0" cy="0"/>
+        </a:xfrm>
+      </p:grpSpPr>
+      <p:sp>
+        <p:nvSpPr>
+          <p:cNvPr id="2" name="Slide Image Placeholder 1"/>
+          <p:cNvSpPr>
+            <a:spLocks noGrp="1" noRot="1" noChangeAspect="1"/>
+          </p:cNvSpPr>
+          <p:nvPr>
+            <p:ph type="sldImg"/>
+          </p:nvPr>
+        </p:nvSpPr>
+        <p:spPr/>
+      </p:sp>
+      <p:sp>
+        <p:nvSpPr>
+          <p:cNvPr id="3" name="Notes Placeholder 2"/>
+          <p:cNvSpPr>
+            <a:spLocks noGrp="1"/>
+          </p:cNvSpPr>
+          <p:nvPr>
+            <p:ph type="body" idx="1"/>
+          </p:nvPr>
+        </p:nvSpPr>
+        <p:spPr/>
+        <p:txBody>
+          <a:bodyPr/>
+          <a:lstStyle/>
+          <a:p>
+            <a:r>
+              <a:rPr lang="en-US" dirty="0"/>
+              <a:t>နှိုင်းယှဉ်နိုင်ဖို့ အဖွဲ့ရဲ့ TF-IDF baseline ကို သူ့ split ပေါ်မှာ ပြန် run ထားပါတယ်။ ဒီ split မှာတော့ baseline ကို ကျော်နိုင်ပါတယ်။ Task 1 မှာ XLM-R က 0.04၊ Task 2 မှာ syllable Bi-LSTM က 0.02 သာပါတယ်။ Baseline score ကျတာရဲ့ တစ်စိတ်တစ်ပိုင်းက original_id မပါတဲ့ row 1,200 ကို ဖယ်ထားလို့ပါ၊ အဲဒီ row တွေက baseline အတွက် လွယ်တဲ့ row တွေပါ။ Class weight မပါရင် XLM-R က Task 2, 3 မှာ minority label တွေကို မခန့်မှန်းနိုင်ပါဘူး။ Syllable က word ထက် ကောင်းတာကိုလည်း ထပ်တွေ့ရပါတယ်။</a:t>
+            </a:r>
+            <a:endParaRPr lang="en-US" dirty="0"/>
+          </a:p>
+        </p:txBody>
+      </p:sp>
+      <p:sp>
+        <p:nvSpPr>
+          <p:cNvPr id="4" name="Slide Number Placeholder 3"/>
+          <p:cNvSpPr>
+            <a:spLocks noGrp="1"/>
+          </p:cNvSpPr>
+          <p:nvPr>
+            <p:ph type="sldNum" sz="quarter" idx="10"/>
+          </p:nvPr>
+        </p:nvSpPr>
+        <p:spPr/>
+        <p:txBody>
+          <a:bodyPr/>
+          <a:lstStyle/>
+          <a:p>
+            <a:fld id="{F7021451-1387-4CA6-816F-3879F97B5CBC}" type="slidenum">
+              <a:rPr lang="en-US"/>
+              <a:t>16</a:t>
+            </a:fld>
+            <a:endParaRPr lang="en-US"/>
+          </a:p>
+        </p:txBody>
+      </p:sp>
+    </p:spTree>
+    <p:extLst>
+      <p:ext uri="{BB962C8B-B14F-4D97-AF65-F5344CB8AC3E}">
+        <p14:creationId xmlns:p14="http://schemas.microsoft.com/office/powerpoint/2010/main" val="1024087016"/>
+      </p:ext>
+    </p:extLst>
+  </p:cSld>
+  <p:clrMapOvr>
+    <a:masterClrMapping/>
+  </p:clrMapOvr>
+</p:notes>
+</file>
+
 <file path=ppt/notesSlides/notesSlide2.xml><?xml version="1.0" encoding="utf-8"?>
 <p:notes xmlns:a="http://schemas.openxmlformats.org/drawingml/2006/main" xmlns:r="http://schemas.openxmlformats.org/officeDocument/2006/relationships" xmlns:p="http://schemas.openxmlformats.org/presentationml/2006/main">
   <p:cSld>
@@ -2018,7 +2196,7 @@
           <a:p>
             <a:r>
               <a:rPr lang="en-US" dirty="0"/>
-              <a:t>Task သုံးခုပါ။ Task 1 က polarized ဟုတ်/မဟုတ် binary။ Task 2 က type 5 မျိုး၊ Task 3 က manifestation 6 မျိုး၊ နှစ်ခုလုံး multi-label ပါ။ အဓိက တွေ့ရှိချက် သုံးခုကို ညာဘက်မှာ ပြထားပါတယ်။</a:t>
+              <a:t>Task သုံးခုပါ။ Task 1 က polarized ဟုတ်/မဟုတ် binary။ Task 2 က type 5 မျိုး၊ Task 3 က manifestation 6 မျိုး၊ နှစ်ခုလုံး multi-label ပါ။ အဓိက တွေ့ရှိချက် လေးခုကို ညာဘက်မှာ ပြထားပါတယ်။</a:t>
             </a:r>
             <a:endParaRPr lang="en-US" dirty="0"/>
           </a:p>
@@ -9732,7 +9910,7 @@
                   <a:schemeClr val="tx1"/>
                 </a:solidFill>
               </a:rPr>
-              <a:t>Test sets have about 1,000 sentences; differences of 0.01 to 0.02 are not reliable.</a:t>
+              <a:t>Test sets have about 1,000 sentences, and a second split changes the ranking; differences of 0.01 to 0.04 are not reliable.</a:t>
             </a:r>
             <a:endParaRPr lang="en-US" sz="2200" dirty="0"/>
           </a:p>
@@ -10195,6 +10373,3544 @@
 </p:sld>
 </file>
 
+<file path=ppt/slides/slide15.xml><?xml version="1.0" encoding="utf-8"?>
+<p:sld xmlns:a="http://schemas.openxmlformats.org/drawingml/2006/main" xmlns:r="http://schemas.openxmlformats.org/officeDocument/2006/relationships" xmlns:p="http://schemas.openxmlformats.org/presentationml/2006/main">
+  <p:cSld name="Slide 4">
+    <p:spTree>
+      <p:nvGrpSpPr>
+        <p:cNvPr id="1" name=""/>
+        <p:cNvGrpSpPr/>
+        <p:nvPr/>
+      </p:nvGrpSpPr>
+      <p:grpSpPr>
+        <a:xfrm>
+          <a:off x="0" y="0"/>
+          <a:ext cx="0" cy="0"/>
+          <a:chOff x="0" y="0"/>
+          <a:chExt cx="0" cy="0"/>
+        </a:xfrm>
+      </p:grpSpPr>
+      <p:sp>
+        <p:nvSpPr>
+          <p:cNvPr id="2" name="Text 0"/>
+          <p:cNvSpPr/>
+          <p:nvPr>
+            <p:ph idx="100" type="title" hasCustomPrompt="1"/>
+          </p:nvPr>
+        </p:nvSpPr>
+        <p:spPr>
+          <a:xfrm>
+            <a:off x="640080" y="411480"/>
+            <a:ext cx="10908792" cy="777240"/>
+          </a:xfrm>
+          <a:prstGeom prst="rect">
+            <a:avLst/>
+          </a:prstGeom>
+          <a:noFill/>
+          <a:ln/>
+        </p:spPr>
+        <p:txBody>
+          <a:bodyPr wrap="square" lIns="0" tIns="0" rIns="0" bIns="0" rtlCol="0" anchor="ctr"/>
+          <a:lstStyle/>
+          <a:p>
+            <a:pPr algn="l" indent="0" marL="0">
+              <a:buNone/>
+            </a:pPr>
+            <a:r>
+              <a:rPr lang="en-US" sz="3000" b="1" dirty="0">
+                <a:solidFill>
+                  <a:schemeClr val="tx1"/>
+                </a:solidFill>
+              </a:rPr>
+              <a:t>A second experiment: multi-task models</a:t>
+            </a:r>
+            <a:endParaRPr lang="en-US" sz="3000" dirty="0"/>
+          </a:p>
+        </p:txBody>
+      </p:sp>
+      <p:graphicFrame>
+        <p:nvGraphicFramePr>
+          <p:cNvPr id="11" name="Table 0"/>
+          <p:cNvGraphicFramePr>
+            <a:graphicFrameLocks noGrp="1"/>
+          </p:cNvGraphicFramePr>
+          <p:nvPr/>
+        </p:nvGraphicFramePr>
+        <p:xfrm>
+          <a:off x="640080" y="1371600"/>
+          <a:ext cx="10908792" cy="3648456"/>
+        </p:xfrm>
+        <a:graphic>
+          <a:graphicData uri="http://schemas.openxmlformats.org/drawingml/2006/table">
+            <a:tbl>
+              <a:tblPr/>
+              <a:tblGrid>
+                <a:gridCol w="2286000"/>
+                <a:gridCol w="3749040"/>
+                <a:gridCol w="4873752"/>
+              </a:tblGrid>
+              <a:tr h="521208">
+                <a:tc>
+                  <a:txBody>
+                    <a:bodyPr/>
+                    <a:lstStyle/>
+                    <a:p>
+                      <a:pPr algn="l" indent="0" marL="0">
+                        <a:buNone/>
+                      </a:pPr>
+                      <a:r>
+                        <a:rPr lang="en-US" sz="1600" b="1" dirty="0">
+                          <a:solidFill>
+                            <a:schemeClr val="tx1"/>
+                          </a:solidFill>
+                        </a:rPr>
+                        <a:t/>
+                      </a:r>
+                      <a:endParaRPr lang="en-US" sz="1600" dirty="0"/>
+                    </a:p>
+                  </a:txBody>
+                  <a:tcPr marL="91440" marR="91440" marT="36576" marB="36576" anchor="ctr">
+                    <a:lnL w="9525" cap="flat" cmpd="sng" algn="ctr">
+                      <a:solidFill>
+                        <a:srgbClr val="E1E5EA"/>
+                      </a:solidFill>
+                      <a:prstDash val="solid"/>
+                      <a:round/>
+                      <a:headEnd type="none" w="med" len="med"/>
+                      <a:tailEnd type="none" w="med" len="med"/>
+                    </a:lnL>
+                    <a:lnR w="9525" cap="flat" cmpd="sng" algn="ctr">
+                      <a:solidFill>
+                        <a:srgbClr val="E1E5EA"/>
+                      </a:solidFill>
+                      <a:prstDash val="solid"/>
+                      <a:round/>
+                      <a:headEnd type="none" w="med" len="med"/>
+                      <a:tailEnd type="none" w="med" len="med"/>
+                    </a:lnR>
+                    <a:lnT w="9525" cap="flat" cmpd="sng" algn="ctr">
+                      <a:solidFill>
+                        <a:srgbClr val="E1E5EA"/>
+                      </a:solidFill>
+                      <a:prstDash val="solid"/>
+                      <a:round/>
+                      <a:headEnd type="none" w="med" len="med"/>
+                      <a:tailEnd type="none" w="med" len="med"/>
+                    </a:lnT>
+                    <a:lnB w="9525" cap="flat" cmpd="sng" algn="ctr">
+                      <a:solidFill>
+                        <a:srgbClr val="E1E5EA"/>
+                      </a:solidFill>
+                      <a:prstDash val="solid"/>
+                      <a:round/>
+                      <a:headEnd type="none" w="med" len="med"/>
+                      <a:tailEnd type="none" w="med" len="med"/>
+                    </a:lnB>
+                    <a:solidFill>
+                      <a:schemeClr val="bg2"/>
+                    </a:solidFill>
+                  </a:tcPr>
+                </a:tc>
+                <a:tc>
+                  <a:txBody>
+                    <a:bodyPr/>
+                    <a:lstStyle/>
+                    <a:p>
+                      <a:pPr algn="l" indent="0" marL="0">
+                        <a:buNone/>
+                      </a:pPr>
+                      <a:r>
+                        <a:rPr lang="en-US" sz="1600" b="1" dirty="0">
+                          <a:solidFill>
+                            <a:schemeClr val="tx1"/>
+                          </a:solidFill>
+                        </a:rPr>
+                        <a:t>Main experiment</a:t>
+                      </a:r>
+                      <a:endParaRPr lang="en-US" sz="1600" dirty="0"/>
+                    </a:p>
+                  </a:txBody>
+                  <a:tcPr marL="91440" marR="91440" marT="36576" marB="36576" anchor="ctr">
+                    <a:lnL w="9525" cap="flat" cmpd="sng" algn="ctr">
+                      <a:solidFill>
+                        <a:srgbClr val="E1E5EA"/>
+                      </a:solidFill>
+                      <a:prstDash val="solid"/>
+                      <a:round/>
+                      <a:headEnd type="none" w="med" len="med"/>
+                      <a:tailEnd type="none" w="med" len="med"/>
+                    </a:lnL>
+                    <a:lnR w="9525" cap="flat" cmpd="sng" algn="ctr">
+                      <a:solidFill>
+                        <a:srgbClr val="E1E5EA"/>
+                      </a:solidFill>
+                      <a:prstDash val="solid"/>
+                      <a:round/>
+                      <a:headEnd type="none" w="med" len="med"/>
+                      <a:tailEnd type="none" w="med" len="med"/>
+                    </a:lnR>
+                    <a:lnT w="9525" cap="flat" cmpd="sng" algn="ctr">
+                      <a:solidFill>
+                        <a:srgbClr val="E1E5EA"/>
+                      </a:solidFill>
+                      <a:prstDash val="solid"/>
+                      <a:round/>
+                      <a:headEnd type="none" w="med" len="med"/>
+                      <a:tailEnd type="none" w="med" len="med"/>
+                    </a:lnT>
+                    <a:lnB w="9525" cap="flat" cmpd="sng" algn="ctr">
+                      <a:solidFill>
+                        <a:srgbClr val="E1E5EA"/>
+                      </a:solidFill>
+                      <a:prstDash val="solid"/>
+                      <a:round/>
+                      <a:headEnd type="none" w="med" len="med"/>
+                      <a:tailEnd type="none" w="med" len="med"/>
+                    </a:lnB>
+                    <a:solidFill>
+                      <a:schemeClr val="bg2"/>
+                    </a:solidFill>
+                  </a:tcPr>
+                </a:tc>
+                <a:tc>
+                  <a:txBody>
+                    <a:bodyPr/>
+                    <a:lstStyle/>
+                    <a:p>
+                      <a:pPr algn="l" indent="0" marL="0">
+                        <a:buNone/>
+                      </a:pPr>
+                      <a:r>
+                        <a:rPr lang="en-US" sz="1600" b="1" dirty="0">
+                          <a:solidFill>
+                            <a:schemeClr val="tx1"/>
+                          </a:solidFill>
+                        </a:rPr>
+                        <a:t>Multi-task experiment</a:t>
+                      </a:r>
+                      <a:endParaRPr lang="en-US" sz="1600" dirty="0"/>
+                    </a:p>
+                  </a:txBody>
+                  <a:tcPr marL="91440" marR="91440" marT="36576" marB="36576" anchor="ctr">
+                    <a:lnL w="9525" cap="flat" cmpd="sng" algn="ctr">
+                      <a:solidFill>
+                        <a:srgbClr val="E1E5EA"/>
+                      </a:solidFill>
+                      <a:prstDash val="solid"/>
+                      <a:round/>
+                      <a:headEnd type="none" w="med" len="med"/>
+                      <a:tailEnd type="none" w="med" len="med"/>
+                    </a:lnL>
+                    <a:lnR w="9525" cap="flat" cmpd="sng" algn="ctr">
+                      <a:solidFill>
+                        <a:srgbClr val="E1E5EA"/>
+                      </a:solidFill>
+                      <a:prstDash val="solid"/>
+                      <a:round/>
+                      <a:headEnd type="none" w="med" len="med"/>
+                      <a:tailEnd type="none" w="med" len="med"/>
+                    </a:lnR>
+                    <a:lnT w="9525" cap="flat" cmpd="sng" algn="ctr">
+                      <a:solidFill>
+                        <a:srgbClr val="E1E5EA"/>
+                      </a:solidFill>
+                      <a:prstDash val="solid"/>
+                      <a:round/>
+                      <a:headEnd type="none" w="med" len="med"/>
+                      <a:tailEnd type="none" w="med" len="med"/>
+                    </a:lnT>
+                    <a:lnB w="9525" cap="flat" cmpd="sng" algn="ctr">
+                      <a:solidFill>
+                        <a:srgbClr val="E1E5EA"/>
+                      </a:solidFill>
+                      <a:prstDash val="solid"/>
+                      <a:round/>
+                      <a:headEnd type="none" w="med" len="med"/>
+                      <a:tailEnd type="none" w="med" len="med"/>
+                    </a:lnB>
+                    <a:solidFill>
+                      <a:schemeClr val="bg2"/>
+                    </a:solidFill>
+                  </a:tcPr>
+                </a:tc>
+              </a:tr>
+              <a:tr h="521208">
+                <a:tc>
+                  <a:txBody>
+                    <a:bodyPr/>
+                    <a:lstStyle/>
+                    <a:p>
+                      <a:pPr algn="l" indent="0" marL="0">
+                        <a:buNone/>
+                      </a:pPr>
+                      <a:r>
+                        <a:rPr lang="en-US" sz="1600" dirty="0">
+                          <a:solidFill>
+                            <a:schemeClr val="tx1"/>
+                          </a:solidFill>
+                        </a:rPr>
+                        <a:t>Sentences</a:t>
+                      </a:r>
+                      <a:endParaRPr lang="en-US" sz="1600" dirty="0"/>
+                    </a:p>
+                  </a:txBody>
+                  <a:tcPr marL="91440" marR="91440" marT="36576" marB="36576" anchor="ctr">
+                    <a:lnL w="9525" cap="flat" cmpd="sng" algn="ctr">
+                      <a:solidFill>
+                        <a:srgbClr val="E1E5EA"/>
+                      </a:solidFill>
+                      <a:prstDash val="solid"/>
+                      <a:round/>
+                      <a:headEnd type="none" w="med" len="med"/>
+                      <a:tailEnd type="none" w="med" len="med"/>
+                    </a:lnL>
+                    <a:lnR w="9525" cap="flat" cmpd="sng" algn="ctr">
+                      <a:solidFill>
+                        <a:srgbClr val="E1E5EA"/>
+                      </a:solidFill>
+                      <a:prstDash val="solid"/>
+                      <a:round/>
+                      <a:headEnd type="none" w="med" len="med"/>
+                      <a:tailEnd type="none" w="med" len="med"/>
+                    </a:lnR>
+                    <a:lnT w="9525" cap="flat" cmpd="sng" algn="ctr">
+                      <a:solidFill>
+                        <a:srgbClr val="E1E5EA"/>
+                      </a:solidFill>
+                      <a:prstDash val="solid"/>
+                      <a:round/>
+                      <a:headEnd type="none" w="med" len="med"/>
+                      <a:tailEnd type="none" w="med" len="med"/>
+                    </a:lnT>
+                    <a:lnB w="9525" cap="flat" cmpd="sng" algn="ctr">
+                      <a:solidFill>
+                        <a:srgbClr val="E1E5EA"/>
+                      </a:solidFill>
+                      <a:prstDash val="solid"/>
+                      <a:round/>
+                      <a:headEnd type="none" w="med" len="med"/>
+                      <a:tailEnd type="none" w="med" len="med"/>
+                    </a:lnB>
+                    <a:solidFill>
+                      <a:srgbClr val="FFFFFF"/>
+                    </a:solidFill>
+                  </a:tcPr>
+                </a:tc>
+                <a:tc>
+                  <a:txBody>
+                    <a:bodyPr/>
+                    <a:lstStyle/>
+                    <a:p>
+                      <a:pPr algn="l" indent="0" marL="0">
+                        <a:buNone/>
+                      </a:pPr>
+                      <a:r>
+                        <a:rPr lang="en-US" sz="1600" dirty="0">
+                          <a:solidFill>
+                            <a:schemeClr val="tx1"/>
+                          </a:solidFill>
+                        </a:rPr>
+                        <a:t>10,710 / 10,710 / 10,116</a:t>
+                      </a:r>
+                      <a:endParaRPr lang="en-US" sz="1600" dirty="0"/>
+                    </a:p>
+                  </a:txBody>
+                  <a:tcPr marL="91440" marR="91440" marT="36576" marB="36576" anchor="ctr">
+                    <a:lnL w="9525" cap="flat" cmpd="sng" algn="ctr">
+                      <a:solidFill>
+                        <a:srgbClr val="E1E5EA"/>
+                      </a:solidFill>
+                      <a:prstDash val="solid"/>
+                      <a:round/>
+                      <a:headEnd type="none" w="med" len="med"/>
+                      <a:tailEnd type="none" w="med" len="med"/>
+                    </a:lnL>
+                    <a:lnR w="9525" cap="flat" cmpd="sng" algn="ctr">
+                      <a:solidFill>
+                        <a:srgbClr val="E1E5EA"/>
+                      </a:solidFill>
+                      <a:prstDash val="solid"/>
+                      <a:round/>
+                      <a:headEnd type="none" w="med" len="med"/>
+                      <a:tailEnd type="none" w="med" len="med"/>
+                    </a:lnR>
+                    <a:lnT w="9525" cap="flat" cmpd="sng" algn="ctr">
+                      <a:solidFill>
+                        <a:srgbClr val="E1E5EA"/>
+                      </a:solidFill>
+                      <a:prstDash val="solid"/>
+                      <a:round/>
+                      <a:headEnd type="none" w="med" len="med"/>
+                      <a:tailEnd type="none" w="med" len="med"/>
+                    </a:lnT>
+                    <a:lnB w="9525" cap="flat" cmpd="sng" algn="ctr">
+                      <a:solidFill>
+                        <a:srgbClr val="E1E5EA"/>
+                      </a:solidFill>
+                      <a:prstDash val="solid"/>
+                      <a:round/>
+                      <a:headEnd type="none" w="med" len="med"/>
+                      <a:tailEnd type="none" w="med" len="med"/>
+                    </a:lnB>
+                    <a:solidFill>
+                      <a:srgbClr val="FFFFFF"/>
+                    </a:solidFill>
+                  </a:tcPr>
+                </a:tc>
+                <a:tc>
+                  <a:txBody>
+                    <a:bodyPr/>
+                    <a:lstStyle/>
+                    <a:p>
+                      <a:pPr algn="l" indent="0" marL="0">
+                        <a:buNone/>
+                      </a:pPr>
+                      <a:r>
+                        <a:rPr lang="en-US" sz="1600" dirty="0">
+                          <a:solidFill>
+                            <a:schemeClr val="tx1"/>
+                          </a:solidFill>
+                        </a:rPr>
+                        <a:t>10,068 for all three tasks</a:t>
+                      </a:r>
+                      <a:endParaRPr lang="en-US" sz="1600" dirty="0"/>
+                    </a:p>
+                  </a:txBody>
+                  <a:tcPr marL="91440" marR="91440" marT="36576" marB="36576" anchor="ctr">
+                    <a:lnL w="9525" cap="flat" cmpd="sng" algn="ctr">
+                      <a:solidFill>
+                        <a:srgbClr val="E1E5EA"/>
+                      </a:solidFill>
+                      <a:prstDash val="solid"/>
+                      <a:round/>
+                      <a:headEnd type="none" w="med" len="med"/>
+                      <a:tailEnd type="none" w="med" len="med"/>
+                    </a:lnL>
+                    <a:lnR w="9525" cap="flat" cmpd="sng" algn="ctr">
+                      <a:solidFill>
+                        <a:srgbClr val="E1E5EA"/>
+                      </a:solidFill>
+                      <a:prstDash val="solid"/>
+                      <a:round/>
+                      <a:headEnd type="none" w="med" len="med"/>
+                      <a:tailEnd type="none" w="med" len="med"/>
+                    </a:lnR>
+                    <a:lnT w="9525" cap="flat" cmpd="sng" algn="ctr">
+                      <a:solidFill>
+                        <a:srgbClr val="E1E5EA"/>
+                      </a:solidFill>
+                      <a:prstDash val="solid"/>
+                      <a:round/>
+                      <a:headEnd type="none" w="med" len="med"/>
+                      <a:tailEnd type="none" w="med" len="med"/>
+                    </a:lnT>
+                    <a:lnB w="9525" cap="flat" cmpd="sng" algn="ctr">
+                      <a:solidFill>
+                        <a:srgbClr val="E1E5EA"/>
+                      </a:solidFill>
+                      <a:prstDash val="solid"/>
+                      <a:round/>
+                      <a:headEnd type="none" w="med" len="med"/>
+                      <a:tailEnd type="none" w="med" len="med"/>
+                    </a:lnB>
+                    <a:solidFill>
+                      <a:srgbClr val="FFFFFF"/>
+                    </a:solidFill>
+                  </a:tcPr>
+                </a:tc>
+              </a:tr>
+              <a:tr h="521208">
+                <a:tc>
+                  <a:txBody>
+                    <a:bodyPr/>
+                    <a:lstStyle/>
+                    <a:p>
+                      <a:pPr algn="l" indent="0" marL="0">
+                        <a:buNone/>
+                      </a:pPr>
+                      <a:r>
+                        <a:rPr lang="en-US" sz="1600" dirty="0">
+                          <a:solidFill>
+                            <a:schemeClr val="tx1"/>
+                          </a:solidFill>
+                        </a:rPr>
+                        <a:t>Cleaning</a:t>
+                      </a:r>
+                      <a:endParaRPr lang="en-US" sz="1600" dirty="0"/>
+                    </a:p>
+                  </a:txBody>
+                  <a:tcPr marL="91440" marR="91440" marT="36576" marB="36576" anchor="ctr">
+                    <a:lnL w="9525" cap="flat" cmpd="sng" algn="ctr">
+                      <a:solidFill>
+                        <a:srgbClr val="E1E5EA"/>
+                      </a:solidFill>
+                      <a:prstDash val="solid"/>
+                      <a:round/>
+                      <a:headEnd type="none" w="med" len="med"/>
+                      <a:tailEnd type="none" w="med" len="med"/>
+                    </a:lnL>
+                    <a:lnR w="9525" cap="flat" cmpd="sng" algn="ctr">
+                      <a:solidFill>
+                        <a:srgbClr val="E1E5EA"/>
+                      </a:solidFill>
+                      <a:prstDash val="solid"/>
+                      <a:round/>
+                      <a:headEnd type="none" w="med" len="med"/>
+                      <a:tailEnd type="none" w="med" len="med"/>
+                    </a:lnR>
+                    <a:lnT w="9525" cap="flat" cmpd="sng" algn="ctr">
+                      <a:solidFill>
+                        <a:srgbClr val="E1E5EA"/>
+                      </a:solidFill>
+                      <a:prstDash val="solid"/>
+                      <a:round/>
+                      <a:headEnd type="none" w="med" len="med"/>
+                      <a:tailEnd type="none" w="med" len="med"/>
+                    </a:lnT>
+                    <a:lnB w="9525" cap="flat" cmpd="sng" algn="ctr">
+                      <a:solidFill>
+                        <a:srgbClr val="E1E5EA"/>
+                      </a:solidFill>
+                      <a:prstDash val="solid"/>
+                      <a:round/>
+                      <a:headEnd type="none" w="med" len="med"/>
+                      <a:tailEnd type="none" w="med" len="med"/>
+                    </a:lnB>
+                    <a:solidFill>
+                      <a:srgbClr val="FFFFFF"/>
+                    </a:solidFill>
+                  </a:tcPr>
+                </a:tc>
+                <a:tc>
+                  <a:txBody>
+                    <a:bodyPr/>
+                    <a:lstStyle/>
+                    <a:p>
+                      <a:pPr algn="l" indent="0" marL="0">
+                        <a:buNone/>
+                      </a:pPr>
+                      <a:r>
+                        <a:rPr lang="en-US" sz="1600" dirty="0">
+                          <a:solidFill>
+                            <a:schemeClr val="tx1"/>
+                          </a:solidFill>
+                        </a:rPr>
+                        <a:t>exact duplicates removed</a:t>
+                      </a:r>
+                      <a:endParaRPr lang="en-US" sz="1600" dirty="0"/>
+                    </a:p>
+                  </a:txBody>
+                  <a:tcPr marL="91440" marR="91440" marT="36576" marB="36576" anchor="ctr">
+                    <a:lnL w="9525" cap="flat" cmpd="sng" algn="ctr">
+                      <a:solidFill>
+                        <a:srgbClr val="E1E5EA"/>
+                      </a:solidFill>
+                      <a:prstDash val="solid"/>
+                      <a:round/>
+                      <a:headEnd type="none" w="med" len="med"/>
+                      <a:tailEnd type="none" w="med" len="med"/>
+                    </a:lnL>
+                    <a:lnR w="9525" cap="flat" cmpd="sng" algn="ctr">
+                      <a:solidFill>
+                        <a:srgbClr val="E1E5EA"/>
+                      </a:solidFill>
+                      <a:prstDash val="solid"/>
+                      <a:round/>
+                      <a:headEnd type="none" w="med" len="med"/>
+                      <a:tailEnd type="none" w="med" len="med"/>
+                    </a:lnR>
+                    <a:lnT w="9525" cap="flat" cmpd="sng" algn="ctr">
+                      <a:solidFill>
+                        <a:srgbClr val="E1E5EA"/>
+                      </a:solidFill>
+                      <a:prstDash val="solid"/>
+                      <a:round/>
+                      <a:headEnd type="none" w="med" len="med"/>
+                      <a:tailEnd type="none" w="med" len="med"/>
+                    </a:lnT>
+                    <a:lnB w="9525" cap="flat" cmpd="sng" algn="ctr">
+                      <a:solidFill>
+                        <a:srgbClr val="E1E5EA"/>
+                      </a:solidFill>
+                      <a:prstDash val="solid"/>
+                      <a:round/>
+                      <a:headEnd type="none" w="med" len="med"/>
+                      <a:tailEnd type="none" w="med" len="med"/>
+                    </a:lnB>
+                    <a:solidFill>
+                      <a:srgbClr val="FFFFFF"/>
+                    </a:solidFill>
+                  </a:tcPr>
+                </a:tc>
+                <a:tc>
+                  <a:txBody>
+                    <a:bodyPr/>
+                    <a:lstStyle/>
+                    <a:p>
+                      <a:pPr algn="l" indent="0" marL="0">
+                        <a:buNone/>
+                      </a:pPr>
+                      <a:r>
+                        <a:rPr lang="en-US" sz="1600" dirty="0">
+                          <a:solidFill>
+                            <a:schemeClr val="tx1"/>
+                          </a:solidFill>
+                        </a:rPr>
+                        <a:t>also drops 1,200 rows without original_id and conflicting duplicates</a:t>
+                      </a:r>
+                      <a:endParaRPr lang="en-US" sz="1600" dirty="0"/>
+                    </a:p>
+                  </a:txBody>
+                  <a:tcPr marL="91440" marR="91440" marT="36576" marB="36576" anchor="ctr">
+                    <a:lnL w="9525" cap="flat" cmpd="sng" algn="ctr">
+                      <a:solidFill>
+                        <a:srgbClr val="E1E5EA"/>
+                      </a:solidFill>
+                      <a:prstDash val="solid"/>
+                      <a:round/>
+                      <a:headEnd type="none" w="med" len="med"/>
+                      <a:tailEnd type="none" w="med" len="med"/>
+                    </a:lnL>
+                    <a:lnR w="9525" cap="flat" cmpd="sng" algn="ctr">
+                      <a:solidFill>
+                        <a:srgbClr val="E1E5EA"/>
+                      </a:solidFill>
+                      <a:prstDash val="solid"/>
+                      <a:round/>
+                      <a:headEnd type="none" w="med" len="med"/>
+                      <a:tailEnd type="none" w="med" len="med"/>
+                    </a:lnR>
+                    <a:lnT w="9525" cap="flat" cmpd="sng" algn="ctr">
+                      <a:solidFill>
+                        <a:srgbClr val="E1E5EA"/>
+                      </a:solidFill>
+                      <a:prstDash val="solid"/>
+                      <a:round/>
+                      <a:headEnd type="none" w="med" len="med"/>
+                      <a:tailEnd type="none" w="med" len="med"/>
+                    </a:lnT>
+                    <a:lnB w="9525" cap="flat" cmpd="sng" algn="ctr">
+                      <a:solidFill>
+                        <a:srgbClr val="E1E5EA"/>
+                      </a:solidFill>
+                      <a:prstDash val="solid"/>
+                      <a:round/>
+                      <a:headEnd type="none" w="med" len="med"/>
+                      <a:tailEnd type="none" w="med" len="med"/>
+                    </a:lnB>
+                    <a:solidFill>
+                      <a:srgbClr val="FFFFFF"/>
+                    </a:solidFill>
+                  </a:tcPr>
+                </a:tc>
+              </a:tr>
+              <a:tr h="521208">
+                <a:tc>
+                  <a:txBody>
+                    <a:bodyPr/>
+                    <a:lstStyle/>
+                    <a:p>
+                      <a:pPr algn="l" indent="0" marL="0">
+                        <a:buNone/>
+                      </a:pPr>
+                      <a:r>
+                        <a:rPr lang="en-US" sz="1600" dirty="0">
+                          <a:solidFill>
+                            <a:schemeClr val="tx1"/>
+                          </a:solidFill>
+                        </a:rPr>
+                        <a:t>Text</a:t>
+                      </a:r>
+                      <a:endParaRPr lang="en-US" sz="1600" dirty="0"/>
+                    </a:p>
+                  </a:txBody>
+                  <a:tcPr marL="91440" marR="91440" marT="36576" marB="36576" anchor="ctr">
+                    <a:lnL w="9525" cap="flat" cmpd="sng" algn="ctr">
+                      <a:solidFill>
+                        <a:srgbClr val="E1E5EA"/>
+                      </a:solidFill>
+                      <a:prstDash val="solid"/>
+                      <a:round/>
+                      <a:headEnd type="none" w="med" len="med"/>
+                      <a:tailEnd type="none" w="med" len="med"/>
+                    </a:lnL>
+                    <a:lnR w="9525" cap="flat" cmpd="sng" algn="ctr">
+                      <a:solidFill>
+                        <a:srgbClr val="E1E5EA"/>
+                      </a:solidFill>
+                      <a:prstDash val="solid"/>
+                      <a:round/>
+                      <a:headEnd type="none" w="med" len="med"/>
+                      <a:tailEnd type="none" w="med" len="med"/>
+                    </a:lnR>
+                    <a:lnT w="9525" cap="flat" cmpd="sng" algn="ctr">
+                      <a:solidFill>
+                        <a:srgbClr val="E1E5EA"/>
+                      </a:solidFill>
+                      <a:prstDash val="solid"/>
+                      <a:round/>
+                      <a:headEnd type="none" w="med" len="med"/>
+                      <a:tailEnd type="none" w="med" len="med"/>
+                    </a:lnT>
+                    <a:lnB w="9525" cap="flat" cmpd="sng" algn="ctr">
+                      <a:solidFill>
+                        <a:srgbClr val="E1E5EA"/>
+                      </a:solidFill>
+                      <a:prstDash val="solid"/>
+                      <a:round/>
+                      <a:headEnd type="none" w="med" len="med"/>
+                      <a:tailEnd type="none" w="med" len="med"/>
+                    </a:lnB>
+                    <a:solidFill>
+                      <a:srgbClr val="FFFFFF"/>
+                    </a:solidFill>
+                  </a:tcPr>
+                </a:tc>
+                <a:tc>
+                  <a:txBody>
+                    <a:bodyPr/>
+                    <a:lstStyle/>
+                    <a:p>
+                      <a:pPr algn="l" indent="0" marL="0">
+                        <a:buNone/>
+                      </a:pPr>
+                      <a:r>
+                        <a:rPr lang="en-US" sz="1600" dirty="0">
+                          <a:solidFill>
+                            <a:schemeClr val="tx1"/>
+                          </a:solidFill>
+                        </a:rPr>
+                        <a:t>original spacing</a:t>
+                      </a:r>
+                      <a:endParaRPr lang="en-US" sz="1600" dirty="0"/>
+                    </a:p>
+                  </a:txBody>
+                  <a:tcPr marL="91440" marR="91440" marT="36576" marB="36576" anchor="ctr">
+                    <a:lnL w="9525" cap="flat" cmpd="sng" algn="ctr">
+                      <a:solidFill>
+                        <a:srgbClr val="E1E5EA"/>
+                      </a:solidFill>
+                      <a:prstDash val="solid"/>
+                      <a:round/>
+                      <a:headEnd type="none" w="med" len="med"/>
+                      <a:tailEnd type="none" w="med" len="med"/>
+                    </a:lnL>
+                    <a:lnR w="9525" cap="flat" cmpd="sng" algn="ctr">
+                      <a:solidFill>
+                        <a:srgbClr val="E1E5EA"/>
+                      </a:solidFill>
+                      <a:prstDash val="solid"/>
+                      <a:round/>
+                      <a:headEnd type="none" w="med" len="med"/>
+                      <a:tailEnd type="none" w="med" len="med"/>
+                    </a:lnR>
+                    <a:lnT w="9525" cap="flat" cmpd="sng" algn="ctr">
+                      <a:solidFill>
+                        <a:srgbClr val="E1E5EA"/>
+                      </a:solidFill>
+                      <a:prstDash val="solid"/>
+                      <a:round/>
+                      <a:headEnd type="none" w="med" len="med"/>
+                      <a:tailEnd type="none" w="med" len="med"/>
+                    </a:lnT>
+                    <a:lnB w="9525" cap="flat" cmpd="sng" algn="ctr">
+                      <a:solidFill>
+                        <a:srgbClr val="E1E5EA"/>
+                      </a:solidFill>
+                      <a:prstDash val="solid"/>
+                      <a:round/>
+                      <a:headEnd type="none" w="med" len="med"/>
+                      <a:tailEnd type="none" w="med" len="med"/>
+                    </a:lnB>
+                    <a:solidFill>
+                      <a:srgbClr val="FFFFFF"/>
+                    </a:solidFill>
+                  </a:tcPr>
+                </a:tc>
+                <a:tc>
+                  <a:txBody>
+                    <a:bodyPr/>
+                    <a:lstStyle/>
+                    <a:p>
+                      <a:pPr algn="l" indent="0" marL="0">
+                        <a:buNone/>
+                      </a:pPr>
+                      <a:r>
+                        <a:rPr lang="en-US" sz="1600" dirty="0">
+                          <a:solidFill>
+                            <a:schemeClr val="tx1"/>
+                          </a:solidFill>
+                        </a:rPr>
+                        <a:t>re-segmented into words (mmdt-tokenizer)</a:t>
+                      </a:r>
+                      <a:endParaRPr lang="en-US" sz="1600" dirty="0"/>
+                    </a:p>
+                  </a:txBody>
+                  <a:tcPr marL="91440" marR="91440" marT="36576" marB="36576" anchor="ctr">
+                    <a:lnL w="9525" cap="flat" cmpd="sng" algn="ctr">
+                      <a:solidFill>
+                        <a:srgbClr val="E1E5EA"/>
+                      </a:solidFill>
+                      <a:prstDash val="solid"/>
+                      <a:round/>
+                      <a:headEnd type="none" w="med" len="med"/>
+                      <a:tailEnd type="none" w="med" len="med"/>
+                    </a:lnL>
+                    <a:lnR w="9525" cap="flat" cmpd="sng" algn="ctr">
+                      <a:solidFill>
+                        <a:srgbClr val="E1E5EA"/>
+                      </a:solidFill>
+                      <a:prstDash val="solid"/>
+                      <a:round/>
+                      <a:headEnd type="none" w="med" len="med"/>
+                      <a:tailEnd type="none" w="med" len="med"/>
+                    </a:lnR>
+                    <a:lnT w="9525" cap="flat" cmpd="sng" algn="ctr">
+                      <a:solidFill>
+                        <a:srgbClr val="E1E5EA"/>
+                      </a:solidFill>
+                      <a:prstDash val="solid"/>
+                      <a:round/>
+                      <a:headEnd type="none" w="med" len="med"/>
+                      <a:tailEnd type="none" w="med" len="med"/>
+                    </a:lnT>
+                    <a:lnB w="9525" cap="flat" cmpd="sng" algn="ctr">
+                      <a:solidFill>
+                        <a:srgbClr val="E1E5EA"/>
+                      </a:solidFill>
+                      <a:prstDash val="solid"/>
+                      <a:round/>
+                      <a:headEnd type="none" w="med" len="med"/>
+                      <a:tailEnd type="none" w="med" len="med"/>
+                    </a:lnB>
+                    <a:solidFill>
+                      <a:srgbClr val="FFFFFF"/>
+                    </a:solidFill>
+                  </a:tcPr>
+                </a:tc>
+              </a:tr>
+              <a:tr h="521208">
+                <a:tc>
+                  <a:txBody>
+                    <a:bodyPr/>
+                    <a:lstStyle/>
+                    <a:p>
+                      <a:pPr algn="l" indent="0" marL="0">
+                        <a:buNone/>
+                      </a:pPr>
+                      <a:r>
+                        <a:rPr lang="en-US" sz="1600" dirty="0">
+                          <a:solidFill>
+                            <a:schemeClr val="tx1"/>
+                          </a:solidFill>
+                        </a:rPr>
+                        <a:t>Non-polarized rows</a:t>
+                      </a:r>
+                      <a:endParaRPr lang="en-US" sz="1600" dirty="0"/>
+                    </a:p>
+                  </a:txBody>
+                  <a:tcPr marL="91440" marR="91440" marT="36576" marB="36576" anchor="ctr">
+                    <a:lnL w="9525" cap="flat" cmpd="sng" algn="ctr">
+                      <a:solidFill>
+                        <a:srgbClr val="E1E5EA"/>
+                      </a:solidFill>
+                      <a:prstDash val="solid"/>
+                      <a:round/>
+                      <a:headEnd type="none" w="med" len="med"/>
+                      <a:tailEnd type="none" w="med" len="med"/>
+                    </a:lnL>
+                    <a:lnR w="9525" cap="flat" cmpd="sng" algn="ctr">
+                      <a:solidFill>
+                        <a:srgbClr val="E1E5EA"/>
+                      </a:solidFill>
+                      <a:prstDash val="solid"/>
+                      <a:round/>
+                      <a:headEnd type="none" w="med" len="med"/>
+                      <a:tailEnd type="none" w="med" len="med"/>
+                    </a:lnR>
+                    <a:lnT w="9525" cap="flat" cmpd="sng" algn="ctr">
+                      <a:solidFill>
+                        <a:srgbClr val="E1E5EA"/>
+                      </a:solidFill>
+                      <a:prstDash val="solid"/>
+                      <a:round/>
+                      <a:headEnd type="none" w="med" len="med"/>
+                      <a:tailEnd type="none" w="med" len="med"/>
+                    </a:lnT>
+                    <a:lnB w="9525" cap="flat" cmpd="sng" algn="ctr">
+                      <a:solidFill>
+                        <a:srgbClr val="E1E5EA"/>
+                      </a:solidFill>
+                      <a:prstDash val="solid"/>
+                      <a:round/>
+                      <a:headEnd type="none" w="med" len="med"/>
+                      <a:tailEnd type="none" w="med" len="med"/>
+                    </a:lnB>
+                    <a:solidFill>
+                      <a:srgbClr val="FFFFFF"/>
+                    </a:solidFill>
+                  </a:tcPr>
+                </a:tc>
+                <a:tc>
+                  <a:txBody>
+                    <a:bodyPr/>
+                    <a:lstStyle/>
+                    <a:p>
+                      <a:pPr algn="l" indent="0" marL="0">
+                        <a:buNone/>
+                      </a:pPr>
+                      <a:r>
+                        <a:rPr lang="en-US" sz="1600" dirty="0">
+                          <a:solidFill>
+                            <a:schemeClr val="tx1"/>
+                          </a:solidFill>
+                        </a:rPr>
+                        <a:t>type / manifestation cleared</a:t>
+                      </a:r>
+                      <a:endParaRPr lang="en-US" sz="1600" dirty="0"/>
+                    </a:p>
+                  </a:txBody>
+                  <a:tcPr marL="91440" marR="91440" marT="36576" marB="36576" anchor="ctr">
+                    <a:lnL w="9525" cap="flat" cmpd="sng" algn="ctr">
+                      <a:solidFill>
+                        <a:srgbClr val="E1E5EA"/>
+                      </a:solidFill>
+                      <a:prstDash val="solid"/>
+                      <a:round/>
+                      <a:headEnd type="none" w="med" len="med"/>
+                      <a:tailEnd type="none" w="med" len="med"/>
+                    </a:lnL>
+                    <a:lnR w="9525" cap="flat" cmpd="sng" algn="ctr">
+                      <a:solidFill>
+                        <a:srgbClr val="E1E5EA"/>
+                      </a:solidFill>
+                      <a:prstDash val="solid"/>
+                      <a:round/>
+                      <a:headEnd type="none" w="med" len="med"/>
+                      <a:tailEnd type="none" w="med" len="med"/>
+                    </a:lnR>
+                    <a:lnT w="9525" cap="flat" cmpd="sng" algn="ctr">
+                      <a:solidFill>
+                        <a:srgbClr val="E1E5EA"/>
+                      </a:solidFill>
+                      <a:prstDash val="solid"/>
+                      <a:round/>
+                      <a:headEnd type="none" w="med" len="med"/>
+                      <a:tailEnd type="none" w="med" len="med"/>
+                    </a:lnT>
+                    <a:lnB w="9525" cap="flat" cmpd="sng" algn="ctr">
+                      <a:solidFill>
+                        <a:srgbClr val="E1E5EA"/>
+                      </a:solidFill>
+                      <a:prstDash val="solid"/>
+                      <a:round/>
+                      <a:headEnd type="none" w="med" len="med"/>
+                      <a:tailEnd type="none" w="med" len="med"/>
+                    </a:lnB>
+                    <a:solidFill>
+                      <a:srgbClr val="FFFFFF"/>
+                    </a:solidFill>
+                  </a:tcPr>
+                </a:tc>
+                <a:tc>
+                  <a:txBody>
+                    <a:bodyPr/>
+                    <a:lstStyle/>
+                    <a:p>
+                      <a:pPr algn="l" indent="0" marL="0">
+                        <a:buNone/>
+                      </a:pPr>
+                      <a:r>
+                        <a:rPr lang="en-US" sz="1600" dirty="0">
+                          <a:solidFill>
+                            <a:schemeClr val="tx1"/>
+                          </a:solidFill>
+                        </a:rPr>
+                        <a:t>kept: 1,903 rows still carry a type</a:t>
+                      </a:r>
+                      <a:endParaRPr lang="en-US" sz="1600" dirty="0"/>
+                    </a:p>
+                  </a:txBody>
+                  <a:tcPr marL="91440" marR="91440" marT="36576" marB="36576" anchor="ctr">
+                    <a:lnL w="9525" cap="flat" cmpd="sng" algn="ctr">
+                      <a:solidFill>
+                        <a:srgbClr val="E1E5EA"/>
+                      </a:solidFill>
+                      <a:prstDash val="solid"/>
+                      <a:round/>
+                      <a:headEnd type="none" w="med" len="med"/>
+                      <a:tailEnd type="none" w="med" len="med"/>
+                    </a:lnL>
+                    <a:lnR w="9525" cap="flat" cmpd="sng" algn="ctr">
+                      <a:solidFill>
+                        <a:srgbClr val="E1E5EA"/>
+                      </a:solidFill>
+                      <a:prstDash val="solid"/>
+                      <a:round/>
+                      <a:headEnd type="none" w="med" len="med"/>
+                      <a:tailEnd type="none" w="med" len="med"/>
+                    </a:lnR>
+                    <a:lnT w="9525" cap="flat" cmpd="sng" algn="ctr">
+                      <a:solidFill>
+                        <a:srgbClr val="E1E5EA"/>
+                      </a:solidFill>
+                      <a:prstDash val="solid"/>
+                      <a:round/>
+                      <a:headEnd type="none" w="med" len="med"/>
+                      <a:tailEnd type="none" w="med" len="med"/>
+                    </a:lnT>
+                    <a:lnB w="9525" cap="flat" cmpd="sng" algn="ctr">
+                      <a:solidFill>
+                        <a:srgbClr val="E1E5EA"/>
+                      </a:solidFill>
+                      <a:prstDash val="solid"/>
+                      <a:round/>
+                      <a:headEnd type="none" w="med" len="med"/>
+                      <a:tailEnd type="none" w="med" len="med"/>
+                    </a:lnB>
+                    <a:solidFill>
+                      <a:srgbClr val="FFFFFF"/>
+                    </a:solidFill>
+                  </a:tcPr>
+                </a:tc>
+              </a:tr>
+              <a:tr h="521208">
+                <a:tc>
+                  <a:txBody>
+                    <a:bodyPr/>
+                    <a:lstStyle/>
+                    <a:p>
+                      <a:pPr algn="l" indent="0" marL="0">
+                        <a:buNone/>
+                      </a:pPr>
+                      <a:r>
+                        <a:rPr lang="en-US" sz="1600" dirty="0">
+                          <a:solidFill>
+                            <a:schemeClr val="tx1"/>
+                          </a:solidFill>
+                        </a:rPr>
+                        <a:t>Split</a:t>
+                      </a:r>
+                      <a:endParaRPr lang="en-US" sz="1600" dirty="0"/>
+                    </a:p>
+                  </a:txBody>
+                  <a:tcPr marL="91440" marR="91440" marT="36576" marB="36576" anchor="ctr">
+                    <a:lnL w="9525" cap="flat" cmpd="sng" algn="ctr">
+                      <a:solidFill>
+                        <a:srgbClr val="E1E5EA"/>
+                      </a:solidFill>
+                      <a:prstDash val="solid"/>
+                      <a:round/>
+                      <a:headEnd type="none" w="med" len="med"/>
+                      <a:tailEnd type="none" w="med" len="med"/>
+                    </a:lnL>
+                    <a:lnR w="9525" cap="flat" cmpd="sng" algn="ctr">
+                      <a:solidFill>
+                        <a:srgbClr val="E1E5EA"/>
+                      </a:solidFill>
+                      <a:prstDash val="solid"/>
+                      <a:round/>
+                      <a:headEnd type="none" w="med" len="med"/>
+                      <a:tailEnd type="none" w="med" len="med"/>
+                    </a:lnR>
+                    <a:lnT w="9525" cap="flat" cmpd="sng" algn="ctr">
+                      <a:solidFill>
+                        <a:srgbClr val="E1E5EA"/>
+                      </a:solidFill>
+                      <a:prstDash val="solid"/>
+                      <a:round/>
+                      <a:headEnd type="none" w="med" len="med"/>
+                      <a:tailEnd type="none" w="med" len="med"/>
+                    </a:lnT>
+                    <a:lnB w="9525" cap="flat" cmpd="sng" algn="ctr">
+                      <a:solidFill>
+                        <a:srgbClr val="E1E5EA"/>
+                      </a:solidFill>
+                      <a:prstDash val="solid"/>
+                      <a:round/>
+                      <a:headEnd type="none" w="med" len="med"/>
+                      <a:tailEnd type="none" w="med" len="med"/>
+                    </a:lnB>
+                    <a:solidFill>
+                      <a:srgbClr val="FFFFFF"/>
+                    </a:solidFill>
+                  </a:tcPr>
+                </a:tc>
+                <a:tc>
+                  <a:txBody>
+                    <a:bodyPr/>
+                    <a:lstStyle/>
+                    <a:p>
+                      <a:pPr algn="l" indent="0" marL="0">
+                        <a:buNone/>
+                      </a:pPr>
+                      <a:r>
+                        <a:rPr lang="en-US" sz="1600" dirty="0">
+                          <a:solidFill>
+                            <a:schemeClr val="tx1"/>
+                          </a:solidFill>
+                        </a:rPr>
+                        <a:t>one 80 / 10 / 10 split per task</a:t>
+                      </a:r>
+                      <a:endParaRPr lang="en-US" sz="1600" dirty="0"/>
+                    </a:p>
+                  </a:txBody>
+                  <a:tcPr marL="91440" marR="91440" marT="36576" marB="36576" anchor="ctr">
+                    <a:lnL w="9525" cap="flat" cmpd="sng" algn="ctr">
+                      <a:solidFill>
+                        <a:srgbClr val="E1E5EA"/>
+                      </a:solidFill>
+                      <a:prstDash val="solid"/>
+                      <a:round/>
+                      <a:headEnd type="none" w="med" len="med"/>
+                      <a:tailEnd type="none" w="med" len="med"/>
+                    </a:lnL>
+                    <a:lnR w="9525" cap="flat" cmpd="sng" algn="ctr">
+                      <a:solidFill>
+                        <a:srgbClr val="E1E5EA"/>
+                      </a:solidFill>
+                      <a:prstDash val="solid"/>
+                      <a:round/>
+                      <a:headEnd type="none" w="med" len="med"/>
+                      <a:tailEnd type="none" w="med" len="med"/>
+                    </a:lnR>
+                    <a:lnT w="9525" cap="flat" cmpd="sng" algn="ctr">
+                      <a:solidFill>
+                        <a:srgbClr val="E1E5EA"/>
+                      </a:solidFill>
+                      <a:prstDash val="solid"/>
+                      <a:round/>
+                      <a:headEnd type="none" w="med" len="med"/>
+                      <a:tailEnd type="none" w="med" len="med"/>
+                    </a:lnT>
+                    <a:lnB w="9525" cap="flat" cmpd="sng" algn="ctr">
+                      <a:solidFill>
+                        <a:srgbClr val="E1E5EA"/>
+                      </a:solidFill>
+                      <a:prstDash val="solid"/>
+                      <a:round/>
+                      <a:headEnd type="none" w="med" len="med"/>
+                      <a:tailEnd type="none" w="med" len="med"/>
+                    </a:lnB>
+                    <a:solidFill>
+                      <a:srgbClr val="FFFFFF"/>
+                    </a:solidFill>
+                  </a:tcPr>
+                </a:tc>
+                <a:tc>
+                  <a:txBody>
+                    <a:bodyPr/>
+                    <a:lstStyle/>
+                    <a:p>
+                      <a:pPr algn="l" indent="0" marL="0">
+                        <a:buNone/>
+                      </a:pPr>
+                      <a:r>
+                        <a:rPr lang="en-US" sz="1600" dirty="0">
+                          <a:solidFill>
+                            <a:schemeClr val="tx1"/>
+                          </a:solidFill>
+                        </a:rPr>
+                        <a:t>one shared multi-label stratified split</a:t>
+                      </a:r>
+                      <a:endParaRPr lang="en-US" sz="1600" dirty="0"/>
+                    </a:p>
+                  </a:txBody>
+                  <a:tcPr marL="91440" marR="91440" marT="36576" marB="36576" anchor="ctr">
+                    <a:lnL w="9525" cap="flat" cmpd="sng" algn="ctr">
+                      <a:solidFill>
+                        <a:srgbClr val="E1E5EA"/>
+                      </a:solidFill>
+                      <a:prstDash val="solid"/>
+                      <a:round/>
+                      <a:headEnd type="none" w="med" len="med"/>
+                      <a:tailEnd type="none" w="med" len="med"/>
+                    </a:lnL>
+                    <a:lnR w="9525" cap="flat" cmpd="sng" algn="ctr">
+                      <a:solidFill>
+                        <a:srgbClr val="E1E5EA"/>
+                      </a:solidFill>
+                      <a:prstDash val="solid"/>
+                      <a:round/>
+                      <a:headEnd type="none" w="med" len="med"/>
+                      <a:tailEnd type="none" w="med" len="med"/>
+                    </a:lnR>
+                    <a:lnT w="9525" cap="flat" cmpd="sng" algn="ctr">
+                      <a:solidFill>
+                        <a:srgbClr val="E1E5EA"/>
+                      </a:solidFill>
+                      <a:prstDash val="solid"/>
+                      <a:round/>
+                      <a:headEnd type="none" w="med" len="med"/>
+                      <a:tailEnd type="none" w="med" len="med"/>
+                    </a:lnT>
+                    <a:lnB w="9525" cap="flat" cmpd="sng" algn="ctr">
+                      <a:solidFill>
+                        <a:srgbClr val="E1E5EA"/>
+                      </a:solidFill>
+                      <a:prstDash val="solid"/>
+                      <a:round/>
+                      <a:headEnd type="none" w="med" len="med"/>
+                      <a:tailEnd type="none" w="med" len="med"/>
+                    </a:lnB>
+                    <a:solidFill>
+                      <a:srgbClr val="FFFFFF"/>
+                    </a:solidFill>
+                  </a:tcPr>
+                </a:tc>
+              </a:tr>
+              <a:tr h="521208">
+                <a:tc>
+                  <a:txBody>
+                    <a:bodyPr/>
+                    <a:lstStyle/>
+                    <a:p>
+                      <a:pPr algn="l" indent="0" marL="0">
+                        <a:buNone/>
+                      </a:pPr>
+                      <a:r>
+                        <a:rPr lang="en-US" sz="1600" dirty="0">
+                          <a:solidFill>
+                            <a:schemeClr val="tx1"/>
+                          </a:solidFill>
+                        </a:rPr>
+                        <a:t>Model</a:t>
+                      </a:r>
+                      <a:endParaRPr lang="en-US" sz="1600" dirty="0"/>
+                    </a:p>
+                  </a:txBody>
+                  <a:tcPr marL="91440" marR="91440" marT="36576" marB="36576" anchor="ctr">
+                    <a:lnL w="9525" cap="flat" cmpd="sng" algn="ctr">
+                      <a:solidFill>
+                        <a:srgbClr val="E1E5EA"/>
+                      </a:solidFill>
+                      <a:prstDash val="solid"/>
+                      <a:round/>
+                      <a:headEnd type="none" w="med" len="med"/>
+                      <a:tailEnd type="none" w="med" len="med"/>
+                    </a:lnL>
+                    <a:lnR w="9525" cap="flat" cmpd="sng" algn="ctr">
+                      <a:solidFill>
+                        <a:srgbClr val="E1E5EA"/>
+                      </a:solidFill>
+                      <a:prstDash val="solid"/>
+                      <a:round/>
+                      <a:headEnd type="none" w="med" len="med"/>
+                      <a:tailEnd type="none" w="med" len="med"/>
+                    </a:lnR>
+                    <a:lnT w="9525" cap="flat" cmpd="sng" algn="ctr">
+                      <a:solidFill>
+                        <a:srgbClr val="E1E5EA"/>
+                      </a:solidFill>
+                      <a:prstDash val="solid"/>
+                      <a:round/>
+                      <a:headEnd type="none" w="med" len="med"/>
+                      <a:tailEnd type="none" w="med" len="med"/>
+                    </a:lnT>
+                    <a:lnB w="9525" cap="flat" cmpd="sng" algn="ctr">
+                      <a:solidFill>
+                        <a:srgbClr val="E1E5EA"/>
+                      </a:solidFill>
+                      <a:prstDash val="solid"/>
+                      <a:round/>
+                      <a:headEnd type="none" w="med" len="med"/>
+                      <a:tailEnd type="none" w="med" len="med"/>
+                    </a:lnB>
+                    <a:solidFill>
+                      <a:srgbClr val="FFFFFF"/>
+                    </a:solidFill>
+                  </a:tcPr>
+                </a:tc>
+                <a:tc>
+                  <a:txBody>
+                    <a:bodyPr/>
+                    <a:lstStyle/>
+                    <a:p>
+                      <a:pPr algn="l" indent="0" marL="0">
+                        <a:buNone/>
+                      </a:pPr>
+                      <a:r>
+                        <a:rPr lang="en-US" sz="1600" dirty="0">
+                          <a:solidFill>
+                            <a:schemeClr val="tx1"/>
+                          </a:solidFill>
+                        </a:rPr>
+                        <a:t>one model per task</a:t>
+                      </a:r>
+                      <a:endParaRPr lang="en-US" sz="1600" dirty="0"/>
+                    </a:p>
+                  </a:txBody>
+                  <a:tcPr marL="91440" marR="91440" marT="36576" marB="36576" anchor="ctr">
+                    <a:lnL w="9525" cap="flat" cmpd="sng" algn="ctr">
+                      <a:solidFill>
+                        <a:srgbClr val="E1E5EA"/>
+                      </a:solidFill>
+                      <a:prstDash val="solid"/>
+                      <a:round/>
+                      <a:headEnd type="none" w="med" len="med"/>
+                      <a:tailEnd type="none" w="med" len="med"/>
+                    </a:lnL>
+                    <a:lnR w="9525" cap="flat" cmpd="sng" algn="ctr">
+                      <a:solidFill>
+                        <a:srgbClr val="E1E5EA"/>
+                      </a:solidFill>
+                      <a:prstDash val="solid"/>
+                      <a:round/>
+                      <a:headEnd type="none" w="med" len="med"/>
+                      <a:tailEnd type="none" w="med" len="med"/>
+                    </a:lnR>
+                    <a:lnT w="9525" cap="flat" cmpd="sng" algn="ctr">
+                      <a:solidFill>
+                        <a:srgbClr val="E1E5EA"/>
+                      </a:solidFill>
+                      <a:prstDash val="solid"/>
+                      <a:round/>
+                      <a:headEnd type="none" w="med" len="med"/>
+                      <a:tailEnd type="none" w="med" len="med"/>
+                    </a:lnT>
+                    <a:lnB w="9525" cap="flat" cmpd="sng" algn="ctr">
+                      <a:solidFill>
+                        <a:srgbClr val="E1E5EA"/>
+                      </a:solidFill>
+                      <a:prstDash val="solid"/>
+                      <a:round/>
+                      <a:headEnd type="none" w="med" len="med"/>
+                      <a:tailEnd type="none" w="med" len="med"/>
+                    </a:lnB>
+                    <a:solidFill>
+                      <a:srgbClr val="FFFFFF"/>
+                    </a:solidFill>
+                  </a:tcPr>
+                </a:tc>
+                <a:tc>
+                  <a:txBody>
+                    <a:bodyPr/>
+                    <a:lstStyle/>
+                    <a:p>
+                      <a:pPr algn="l" indent="0" marL="0">
+                        <a:buNone/>
+                      </a:pPr>
+                      <a:r>
+                        <a:rPr lang="en-US" sz="1600" dirty="0">
+                          <a:solidFill>
+                            <a:schemeClr val="tx1"/>
+                          </a:solidFill>
+                        </a:rPr>
+                        <a:t>one encoder with three output heads</a:t>
+                      </a:r>
+                      <a:endParaRPr lang="en-US" sz="1600" dirty="0"/>
+                    </a:p>
+                  </a:txBody>
+                  <a:tcPr marL="91440" marR="91440" marT="36576" marB="36576" anchor="ctr">
+                    <a:lnL w="9525" cap="flat" cmpd="sng" algn="ctr">
+                      <a:solidFill>
+                        <a:srgbClr val="E1E5EA"/>
+                      </a:solidFill>
+                      <a:prstDash val="solid"/>
+                      <a:round/>
+                      <a:headEnd type="none" w="med" len="med"/>
+                      <a:tailEnd type="none" w="med" len="med"/>
+                    </a:lnL>
+                    <a:lnR w="9525" cap="flat" cmpd="sng" algn="ctr">
+                      <a:solidFill>
+                        <a:srgbClr val="E1E5EA"/>
+                      </a:solidFill>
+                      <a:prstDash val="solid"/>
+                      <a:round/>
+                      <a:headEnd type="none" w="med" len="med"/>
+                      <a:tailEnd type="none" w="med" len="med"/>
+                    </a:lnR>
+                    <a:lnT w="9525" cap="flat" cmpd="sng" algn="ctr">
+                      <a:solidFill>
+                        <a:srgbClr val="E1E5EA"/>
+                      </a:solidFill>
+                      <a:prstDash val="solid"/>
+                      <a:round/>
+                      <a:headEnd type="none" w="med" len="med"/>
+                      <a:tailEnd type="none" w="med" len="med"/>
+                    </a:lnT>
+                    <a:lnB w="9525" cap="flat" cmpd="sng" algn="ctr">
+                      <a:solidFill>
+                        <a:srgbClr val="E1E5EA"/>
+                      </a:solidFill>
+                      <a:prstDash val="solid"/>
+                      <a:round/>
+                      <a:headEnd type="none" w="med" len="med"/>
+                      <a:tailEnd type="none" w="med" len="med"/>
+                    </a:lnB>
+                    <a:solidFill>
+                      <a:srgbClr val="FFFFFF"/>
+                    </a:solidFill>
+                  </a:tcPr>
+                </a:tc>
+              </a:tr>
+            </a:tbl>
+          </a:graphicData>
+        </a:graphic>
+      </p:graphicFrame>
+      <p:sp>
+        <p:nvSpPr>
+          <p:cNvPr id="5" name="Text 5"/>
+          <p:cNvSpPr txBox="1"/>
+          <p:nvPr/>
+        </p:nvSpPr>
+        <p:spPr>
+          <a:xfrm>
+            <a:off x="640080" y="5212080"/>
+            <a:ext cx="10908792" cy="914400"/>
+          </a:xfrm>
+          <a:prstGeom prst="rect">
+            <a:avLst/>
+          </a:prstGeom>
+          <a:noFill/>
+          <a:ln/>
+        </p:spPr>
+        <p:txBody>
+          <a:bodyPr wrap="square" lIns="0" tIns="0" rIns="0" bIns="0" rtlCol="0" anchor="t"/>
+          <a:lstStyle/>
+          <a:p>
+            <a:pPr indent="0" marL="0">
+              <a:spcAft>
+                <a:spcPts val="1000"/>
+              </a:spcAft>
+              <a:buNone/>
+            </a:pPr>
+            <a:r>
+              <a:rPr lang="en-US" sz="1800" b="1" dirty="0">
+                <a:solidFill>
+                  <a:schemeClr val="tx1"/>
+                </a:solidFill>
+              </a:rPr>
+              <a:t>Models: </a:t>
+            </a:r>
+            <a:r>
+              <a:rPr lang="en-US" sz="1800" dirty="0">
+                <a:solidFill>
+                  <a:schemeClr val="tx1"/>
+                </a:solidFill>
+              </a:rPr>
+              <a:t>XLM-RoBERTa, mBERT, Bi-LSTM on words and on syllables; Kaggle T4 GPU; epoch chosen on validation.</a:t>
+            </a:r>
+            <a:endParaRPr lang="en-US" sz="1800" dirty="0"/>
+          </a:p>
+          <a:p>
+            <a:pPr indent="0" marL="0">
+              <a:spcAft>
+                <a:spcPts val="1000"/>
+              </a:spcAft>
+              <a:buNone/>
+            </a:pPr>
+            <a:r>
+              <a:rPr lang="en-US" sz="1800" b="1" dirty="0">
+                <a:solidFill>
+                  <a:schemeClr val="tx1"/>
+                </a:solidFill>
+              </a:rPr>
+              <a:t>Not comparable directly: </a:t>
+            </a:r>
+            <a:r>
+              <a:rPr lang="en-US" sz="1800" dirty="0">
+                <a:solidFill>
+                  <a:schemeClr val="tx1"/>
+                </a:solidFill>
+              </a:rPr>
+              <a:t>about half of his test sentences are in our training splits.</a:t>
+            </a:r>
+            <a:endParaRPr lang="en-US" sz="1800" dirty="0"/>
+          </a:p>
+        </p:txBody>
+      </p:sp>
+      <p:sp>
+        <p:nvSpPr>
+          <p:cNvPr id="25" name="Slide Number Placeholder 0"/>
+          <p:cNvSpPr>
+            <a:spLocks noGrp="1"/>
+          </p:cNvSpPr>
+          <p:nvPr>
+            <p:ph type="sldNum" sz="quarter" idx="4294967295"/>
+          </p:nvPr>
+        </p:nvSpPr>
+        <p:spPr>
+          <a:xfrm>
+            <a:off x="11000232" y="6355080"/>
+            <a:ext cx="548640" cy="274320"/>
+          </a:xfrm>
+          <a:prstGeom prst="rect">
+            <a:avLst/>
+          </a:prstGeom>
+          <a:extLst>
+            <a:ext uri="{C572A759-6A51-4108-AA02-DFA0A04FC94B}">
+              <ma14:wrappingTextBoxFlag xmlns:ma14="http://schemas.microsoft.com/office/mac/drawingml/2011/main" val="0"/>
+            </a:ext>
+          </a:extLst>
+        </p:spPr>
+        <p:txBody>
+          <a:bodyPr/>
+          <a:lstStyle>
+            <a:lvl1pPr>
+              <a:defRPr sz="1100">
+                <a:solidFill>
+                  <a:schemeClr val="tx2"/>
+                </a:solidFill>
+              </a:defRPr>
+            </a:lvl1pPr>
+          </a:lstStyle>
+          <a:p>
+            <a:pPr algn="r"/>
+            <a:fld id="{F7021451-1387-4CA6-816F-3879F97B5CBC}" type="slidenum">
+              <a:rPr b="0" lang="en-US"/>
+              <a:t>4</a:t>
+            </a:fld>
+            <a:endParaRPr lang="en-US"/>
+          </a:p>
+        </p:txBody>
+      </p:sp>
+    </p:spTree>
+  </p:cSld>
+  <p:clrMapOvr>
+    <a:masterClrMapping/>
+  </p:clrMapOvr>
+</p:sld>
+</file>
+
+<file path=ppt/slides/slide16.xml><?xml version="1.0" encoding="utf-8"?>
+<p:sld xmlns:a="http://schemas.openxmlformats.org/drawingml/2006/main" xmlns:r="http://schemas.openxmlformats.org/officeDocument/2006/relationships" xmlns:p="http://schemas.openxmlformats.org/presentationml/2006/main">
+  <p:cSld name="Slide 10">
+    <p:spTree>
+      <p:nvGrpSpPr>
+        <p:cNvPr id="1" name=""/>
+        <p:cNvGrpSpPr/>
+        <p:nvPr/>
+      </p:nvGrpSpPr>
+      <p:grpSpPr>
+        <a:xfrm>
+          <a:off x="0" y="0"/>
+          <a:ext cx="0" cy="0"/>
+          <a:chOff x="0" y="0"/>
+          <a:chExt cx="0" cy="0"/>
+        </a:xfrm>
+      </p:grpSpPr>
+      <p:sp>
+        <p:nvSpPr>
+          <p:cNvPr id="2" name="Text 0"/>
+          <p:cNvSpPr/>
+          <p:nvPr>
+            <p:ph idx="100" type="title" hasCustomPrompt="1"/>
+          </p:nvPr>
+        </p:nvSpPr>
+        <p:spPr>
+          <a:xfrm>
+            <a:off x="640080" y="411480"/>
+            <a:ext cx="10908792" cy="777240"/>
+          </a:xfrm>
+          <a:prstGeom prst="rect">
+            <a:avLst/>
+          </a:prstGeom>
+          <a:noFill/>
+          <a:ln/>
+        </p:spPr>
+        <p:txBody>
+          <a:bodyPr wrap="square" lIns="0" tIns="0" rIns="0" bIns="0" rtlCol="0" anchor="ctr"/>
+          <a:lstStyle/>
+          <a:p>
+            <a:pPr algn="l" indent="0" marL="0">
+              <a:buNone/>
+            </a:pPr>
+            <a:r>
+              <a:rPr lang="en-US" sz="3000" b="1" dirty="0">
+                <a:solidFill>
+                  <a:schemeClr val="tx1"/>
+                </a:solidFill>
+              </a:rPr>
+              <a:t>On a second split, the baseline is beaten</a:t>
+            </a:r>
+            <a:endParaRPr lang="en-US" sz="3000" dirty="0"/>
+          </a:p>
+        </p:txBody>
+      </p:sp>
+      <p:graphicFrame>
+        <p:nvGraphicFramePr>
+          <p:cNvPr id="11" name="Table 0"/>
+          <p:cNvGraphicFramePr>
+            <a:graphicFrameLocks noGrp="1"/>
+          </p:cNvGraphicFramePr>
+          <p:nvPr/>
+        </p:nvGraphicFramePr>
+        <p:xfrm>
+          <a:off x="640080" y="1417320"/>
+          <a:ext cx="6309360" cy="3840480"/>
+        </p:xfrm>
+        <a:graphic>
+          <a:graphicData uri="http://schemas.openxmlformats.org/drawingml/2006/table">
+            <a:tbl>
+              <a:tblPr/>
+              <a:tblGrid>
+                <a:gridCol w="3017520"/>
+                <a:gridCol w="1097280"/>
+                <a:gridCol w="1097280"/>
+                <a:gridCol w="1097280"/>
+              </a:tblGrid>
+              <a:tr h="548640">
+                <a:tc>
+                  <a:txBody>
+                    <a:bodyPr/>
+                    <a:lstStyle/>
+                    <a:p>
+                      <a:pPr algn="l" indent="0" marL="0">
+                        <a:buNone/>
+                      </a:pPr>
+                      <a:r>
+                        <a:rPr lang="en-US" sz="1600" b="1" dirty="0">
+                          <a:solidFill>
+                            <a:schemeClr val="tx1"/>
+                          </a:solidFill>
+                        </a:rPr>
+                        <a:t>Model</a:t>
+                      </a:r>
+                      <a:endParaRPr lang="en-US" sz="1600" dirty="0"/>
+                    </a:p>
+                  </a:txBody>
+                  <a:tcPr marL="91440" marR="91440" marT="36576" marB="36576" anchor="ctr">
+                    <a:lnL w="9525" cap="flat" cmpd="sng" algn="ctr">
+                      <a:solidFill>
+                        <a:srgbClr val="E1E5EA"/>
+                      </a:solidFill>
+                      <a:prstDash val="solid"/>
+                      <a:round/>
+                      <a:headEnd type="none" w="med" len="med"/>
+                      <a:tailEnd type="none" w="med" len="med"/>
+                    </a:lnL>
+                    <a:lnR w="9525" cap="flat" cmpd="sng" algn="ctr">
+                      <a:solidFill>
+                        <a:srgbClr val="E1E5EA"/>
+                      </a:solidFill>
+                      <a:prstDash val="solid"/>
+                      <a:round/>
+                      <a:headEnd type="none" w="med" len="med"/>
+                      <a:tailEnd type="none" w="med" len="med"/>
+                    </a:lnR>
+                    <a:lnT w="9525" cap="flat" cmpd="sng" algn="ctr">
+                      <a:solidFill>
+                        <a:srgbClr val="E1E5EA"/>
+                      </a:solidFill>
+                      <a:prstDash val="solid"/>
+                      <a:round/>
+                      <a:headEnd type="none" w="med" len="med"/>
+                      <a:tailEnd type="none" w="med" len="med"/>
+                    </a:lnT>
+                    <a:lnB w="9525" cap="flat" cmpd="sng" algn="ctr">
+                      <a:solidFill>
+                        <a:srgbClr val="E1E5EA"/>
+                      </a:solidFill>
+                      <a:prstDash val="solid"/>
+                      <a:round/>
+                      <a:headEnd type="none" w="med" len="med"/>
+                      <a:tailEnd type="none" w="med" len="med"/>
+                    </a:lnB>
+                    <a:solidFill>
+                      <a:schemeClr val="bg2"/>
+                    </a:solidFill>
+                  </a:tcPr>
+                </a:tc>
+                <a:tc>
+                  <a:txBody>
+                    <a:bodyPr/>
+                    <a:lstStyle/>
+                    <a:p>
+                      <a:pPr algn="ctr" indent="0" marL="0">
+                        <a:buNone/>
+                      </a:pPr>
+                      <a:r>
+                        <a:rPr lang="en-US" sz="1600" b="1" dirty="0">
+                          <a:solidFill>
+                            <a:schemeClr val="tx1"/>
+                          </a:solidFill>
+                        </a:rPr>
+                        <a:t>Task 1</a:t>
+                      </a:r>
+                      <a:endParaRPr lang="en-US" sz="1600" dirty="0"/>
+                    </a:p>
+                  </a:txBody>
+                  <a:tcPr marL="91440" marR="91440" marT="36576" marB="36576" anchor="ctr">
+                    <a:lnL w="9525" cap="flat" cmpd="sng" algn="ctr">
+                      <a:solidFill>
+                        <a:srgbClr val="E1E5EA"/>
+                      </a:solidFill>
+                      <a:prstDash val="solid"/>
+                      <a:round/>
+                      <a:headEnd type="none" w="med" len="med"/>
+                      <a:tailEnd type="none" w="med" len="med"/>
+                    </a:lnL>
+                    <a:lnR w="9525" cap="flat" cmpd="sng" algn="ctr">
+                      <a:solidFill>
+                        <a:srgbClr val="E1E5EA"/>
+                      </a:solidFill>
+                      <a:prstDash val="solid"/>
+                      <a:round/>
+                      <a:headEnd type="none" w="med" len="med"/>
+                      <a:tailEnd type="none" w="med" len="med"/>
+                    </a:lnR>
+                    <a:lnT w="9525" cap="flat" cmpd="sng" algn="ctr">
+                      <a:solidFill>
+                        <a:srgbClr val="E1E5EA"/>
+                      </a:solidFill>
+                      <a:prstDash val="solid"/>
+                      <a:round/>
+                      <a:headEnd type="none" w="med" len="med"/>
+                      <a:tailEnd type="none" w="med" len="med"/>
+                    </a:lnT>
+                    <a:lnB w="9525" cap="flat" cmpd="sng" algn="ctr">
+                      <a:solidFill>
+                        <a:srgbClr val="E1E5EA"/>
+                      </a:solidFill>
+                      <a:prstDash val="solid"/>
+                      <a:round/>
+                      <a:headEnd type="none" w="med" len="med"/>
+                      <a:tailEnd type="none" w="med" len="med"/>
+                    </a:lnB>
+                    <a:solidFill>
+                      <a:schemeClr val="bg2"/>
+                    </a:solidFill>
+                  </a:tcPr>
+                </a:tc>
+                <a:tc>
+                  <a:txBody>
+                    <a:bodyPr/>
+                    <a:lstStyle/>
+                    <a:p>
+                      <a:pPr algn="ctr" indent="0" marL="0">
+                        <a:buNone/>
+                      </a:pPr>
+                      <a:r>
+                        <a:rPr lang="en-US" sz="1600" b="1" dirty="0">
+                          <a:solidFill>
+                            <a:schemeClr val="tx1"/>
+                          </a:solidFill>
+                        </a:rPr>
+                        <a:t>Task 2</a:t>
+                      </a:r>
+                      <a:endParaRPr lang="en-US" sz="1600" dirty="0"/>
+                    </a:p>
+                  </a:txBody>
+                  <a:tcPr marL="91440" marR="91440" marT="36576" marB="36576" anchor="ctr">
+                    <a:lnL w="9525" cap="flat" cmpd="sng" algn="ctr">
+                      <a:solidFill>
+                        <a:srgbClr val="E1E5EA"/>
+                      </a:solidFill>
+                      <a:prstDash val="solid"/>
+                      <a:round/>
+                      <a:headEnd type="none" w="med" len="med"/>
+                      <a:tailEnd type="none" w="med" len="med"/>
+                    </a:lnL>
+                    <a:lnR w="9525" cap="flat" cmpd="sng" algn="ctr">
+                      <a:solidFill>
+                        <a:srgbClr val="E1E5EA"/>
+                      </a:solidFill>
+                      <a:prstDash val="solid"/>
+                      <a:round/>
+                      <a:headEnd type="none" w="med" len="med"/>
+                      <a:tailEnd type="none" w="med" len="med"/>
+                    </a:lnR>
+                    <a:lnT w="9525" cap="flat" cmpd="sng" algn="ctr">
+                      <a:solidFill>
+                        <a:srgbClr val="E1E5EA"/>
+                      </a:solidFill>
+                      <a:prstDash val="solid"/>
+                      <a:round/>
+                      <a:headEnd type="none" w="med" len="med"/>
+                      <a:tailEnd type="none" w="med" len="med"/>
+                    </a:lnT>
+                    <a:lnB w="9525" cap="flat" cmpd="sng" algn="ctr">
+                      <a:solidFill>
+                        <a:srgbClr val="E1E5EA"/>
+                      </a:solidFill>
+                      <a:prstDash val="solid"/>
+                      <a:round/>
+                      <a:headEnd type="none" w="med" len="med"/>
+                      <a:tailEnd type="none" w="med" len="med"/>
+                    </a:lnB>
+                    <a:solidFill>
+                      <a:schemeClr val="bg2"/>
+                    </a:solidFill>
+                  </a:tcPr>
+                </a:tc>
+                <a:tc>
+                  <a:txBody>
+                    <a:bodyPr/>
+                    <a:lstStyle/>
+                    <a:p>
+                      <a:pPr algn="ctr" indent="0" marL="0">
+                        <a:buNone/>
+                      </a:pPr>
+                      <a:r>
+                        <a:rPr lang="en-US" sz="1600" b="1" dirty="0">
+                          <a:solidFill>
+                            <a:schemeClr val="tx1"/>
+                          </a:solidFill>
+                        </a:rPr>
+                        <a:t>Task 3</a:t>
+                      </a:r>
+                      <a:endParaRPr lang="en-US" sz="1600" dirty="0"/>
+                    </a:p>
+                  </a:txBody>
+                  <a:tcPr marL="91440" marR="91440" marT="36576" marB="36576" anchor="ctr">
+                    <a:lnL w="9525" cap="flat" cmpd="sng" algn="ctr">
+                      <a:solidFill>
+                        <a:srgbClr val="E1E5EA"/>
+                      </a:solidFill>
+                      <a:prstDash val="solid"/>
+                      <a:round/>
+                      <a:headEnd type="none" w="med" len="med"/>
+                      <a:tailEnd type="none" w="med" len="med"/>
+                    </a:lnL>
+                    <a:lnR w="9525" cap="flat" cmpd="sng" algn="ctr">
+                      <a:solidFill>
+                        <a:srgbClr val="E1E5EA"/>
+                      </a:solidFill>
+                      <a:prstDash val="solid"/>
+                      <a:round/>
+                      <a:headEnd type="none" w="med" len="med"/>
+                      <a:tailEnd type="none" w="med" len="med"/>
+                    </a:lnR>
+                    <a:lnT w="9525" cap="flat" cmpd="sng" algn="ctr">
+                      <a:solidFill>
+                        <a:srgbClr val="E1E5EA"/>
+                      </a:solidFill>
+                      <a:prstDash val="solid"/>
+                      <a:round/>
+                      <a:headEnd type="none" w="med" len="med"/>
+                      <a:tailEnd type="none" w="med" len="med"/>
+                    </a:lnT>
+                    <a:lnB w="9525" cap="flat" cmpd="sng" algn="ctr">
+                      <a:solidFill>
+                        <a:srgbClr val="E1E5EA"/>
+                      </a:solidFill>
+                      <a:prstDash val="solid"/>
+                      <a:round/>
+                      <a:headEnd type="none" w="med" len="med"/>
+                      <a:tailEnd type="none" w="med" len="med"/>
+                    </a:lnB>
+                    <a:solidFill>
+                      <a:schemeClr val="bg2"/>
+                    </a:solidFill>
+                  </a:tcPr>
+                </a:tc>
+              </a:tr>
+              <a:tr h="548640">
+                <a:tc>
+                  <a:txBody>
+                    <a:bodyPr/>
+                    <a:lstStyle/>
+                    <a:p>
+                      <a:pPr algn="l" indent="0" marL="0">
+                        <a:buNone/>
+                      </a:pPr>
+                      <a:r>
+                        <a:rPr lang="en-US" sz="1600" dirty="0">
+                          <a:solidFill>
+                            <a:schemeClr val="tx1"/>
+                          </a:solidFill>
+                        </a:rPr>
+                        <a:t>TF-IDF + linear (ours)</a:t>
+                      </a:r>
+                      <a:endParaRPr lang="en-US" sz="1600" dirty="0"/>
+                    </a:p>
+                  </a:txBody>
+                  <a:tcPr marL="91440" marR="91440" marT="36576" marB="36576" anchor="ctr">
+                    <a:lnL w="9525" cap="flat" cmpd="sng" algn="ctr">
+                      <a:solidFill>
+                        <a:srgbClr val="E1E5EA"/>
+                      </a:solidFill>
+                      <a:prstDash val="solid"/>
+                      <a:round/>
+                      <a:headEnd type="none" w="med" len="med"/>
+                      <a:tailEnd type="none" w="med" len="med"/>
+                    </a:lnL>
+                    <a:lnR w="9525" cap="flat" cmpd="sng" algn="ctr">
+                      <a:solidFill>
+                        <a:srgbClr val="E1E5EA"/>
+                      </a:solidFill>
+                      <a:prstDash val="solid"/>
+                      <a:round/>
+                      <a:headEnd type="none" w="med" len="med"/>
+                      <a:tailEnd type="none" w="med" len="med"/>
+                    </a:lnR>
+                    <a:lnT w="9525" cap="flat" cmpd="sng" algn="ctr">
+                      <a:solidFill>
+                        <a:srgbClr val="E1E5EA"/>
+                      </a:solidFill>
+                      <a:prstDash val="solid"/>
+                      <a:round/>
+                      <a:headEnd type="none" w="med" len="med"/>
+                      <a:tailEnd type="none" w="med" len="med"/>
+                    </a:lnT>
+                    <a:lnB w="9525" cap="flat" cmpd="sng" algn="ctr">
+                      <a:solidFill>
+                        <a:srgbClr val="E1E5EA"/>
+                      </a:solidFill>
+                      <a:prstDash val="solid"/>
+                      <a:round/>
+                      <a:headEnd type="none" w="med" len="med"/>
+                      <a:tailEnd type="none" w="med" len="med"/>
+                    </a:lnB>
+                    <a:solidFill>
+                      <a:srgbClr val="FFFFFF"/>
+                    </a:solidFill>
+                  </a:tcPr>
+                </a:tc>
+                <a:tc>
+                  <a:txBody>
+                    <a:bodyPr/>
+                    <a:lstStyle/>
+                    <a:p>
+                      <a:pPr algn="ctr" indent="0" marL="0">
+                        <a:buNone/>
+                      </a:pPr>
+                      <a:r>
+                        <a:rPr lang="en-US" sz="1600" dirty="0">
+                          <a:solidFill>
+                            <a:schemeClr val="tx1"/>
+                          </a:solidFill>
+                        </a:rPr>
+                        <a:t>0.733</a:t>
+                      </a:r>
+                      <a:endParaRPr lang="en-US" sz="1600" dirty="0"/>
+                    </a:p>
+                  </a:txBody>
+                  <a:tcPr marL="91440" marR="91440" marT="36576" marB="36576" anchor="ctr">
+                    <a:lnL w="9525" cap="flat" cmpd="sng" algn="ctr">
+                      <a:solidFill>
+                        <a:srgbClr val="E1E5EA"/>
+                      </a:solidFill>
+                      <a:prstDash val="solid"/>
+                      <a:round/>
+                      <a:headEnd type="none" w="med" len="med"/>
+                      <a:tailEnd type="none" w="med" len="med"/>
+                    </a:lnL>
+                    <a:lnR w="9525" cap="flat" cmpd="sng" algn="ctr">
+                      <a:solidFill>
+                        <a:srgbClr val="E1E5EA"/>
+                      </a:solidFill>
+                      <a:prstDash val="solid"/>
+                      <a:round/>
+                      <a:headEnd type="none" w="med" len="med"/>
+                      <a:tailEnd type="none" w="med" len="med"/>
+                    </a:lnR>
+                    <a:lnT w="9525" cap="flat" cmpd="sng" algn="ctr">
+                      <a:solidFill>
+                        <a:srgbClr val="E1E5EA"/>
+                      </a:solidFill>
+                      <a:prstDash val="solid"/>
+                      <a:round/>
+                      <a:headEnd type="none" w="med" len="med"/>
+                      <a:tailEnd type="none" w="med" len="med"/>
+                    </a:lnT>
+                    <a:lnB w="9525" cap="flat" cmpd="sng" algn="ctr">
+                      <a:solidFill>
+                        <a:srgbClr val="E1E5EA"/>
+                      </a:solidFill>
+                      <a:prstDash val="solid"/>
+                      <a:round/>
+                      <a:headEnd type="none" w="med" len="med"/>
+                      <a:tailEnd type="none" w="med" len="med"/>
+                    </a:lnB>
+                    <a:solidFill>
+                      <a:srgbClr val="FFFFFF"/>
+                    </a:solidFill>
+                  </a:tcPr>
+                </a:tc>
+                <a:tc>
+                  <a:txBody>
+                    <a:bodyPr/>
+                    <a:lstStyle/>
+                    <a:p>
+                      <a:pPr algn="ctr" indent="0" marL="0">
+                        <a:buNone/>
+                      </a:pPr>
+                      <a:r>
+                        <a:rPr lang="en-US" sz="1600" dirty="0">
+                          <a:solidFill>
+                            <a:schemeClr val="tx1"/>
+                          </a:solidFill>
+                        </a:rPr>
+                        <a:t>0.583</a:t>
+                      </a:r>
+                      <a:endParaRPr lang="en-US" sz="1600" dirty="0"/>
+                    </a:p>
+                  </a:txBody>
+                  <a:tcPr marL="91440" marR="91440" marT="36576" marB="36576" anchor="ctr">
+                    <a:lnL w="9525" cap="flat" cmpd="sng" algn="ctr">
+                      <a:solidFill>
+                        <a:srgbClr val="E1E5EA"/>
+                      </a:solidFill>
+                      <a:prstDash val="solid"/>
+                      <a:round/>
+                      <a:headEnd type="none" w="med" len="med"/>
+                      <a:tailEnd type="none" w="med" len="med"/>
+                    </a:lnL>
+                    <a:lnR w="9525" cap="flat" cmpd="sng" algn="ctr">
+                      <a:solidFill>
+                        <a:srgbClr val="E1E5EA"/>
+                      </a:solidFill>
+                      <a:prstDash val="solid"/>
+                      <a:round/>
+                      <a:headEnd type="none" w="med" len="med"/>
+                      <a:tailEnd type="none" w="med" len="med"/>
+                    </a:lnR>
+                    <a:lnT w="9525" cap="flat" cmpd="sng" algn="ctr">
+                      <a:solidFill>
+                        <a:srgbClr val="E1E5EA"/>
+                      </a:solidFill>
+                      <a:prstDash val="solid"/>
+                      <a:round/>
+                      <a:headEnd type="none" w="med" len="med"/>
+                      <a:tailEnd type="none" w="med" len="med"/>
+                    </a:lnT>
+                    <a:lnB w="9525" cap="flat" cmpd="sng" algn="ctr">
+                      <a:solidFill>
+                        <a:srgbClr val="E1E5EA"/>
+                      </a:solidFill>
+                      <a:prstDash val="solid"/>
+                      <a:round/>
+                      <a:headEnd type="none" w="med" len="med"/>
+                      <a:tailEnd type="none" w="med" len="med"/>
+                    </a:lnB>
+                    <a:solidFill>
+                      <a:srgbClr val="FFFFFF"/>
+                    </a:solidFill>
+                  </a:tcPr>
+                </a:tc>
+                <a:tc>
+                  <a:txBody>
+                    <a:bodyPr/>
+                    <a:lstStyle/>
+                    <a:p>
+                      <a:pPr algn="ctr" indent="0" marL="0">
+                        <a:buNone/>
+                      </a:pPr>
+                      <a:r>
+                        <a:rPr lang="en-US" sz="1600" dirty="0">
+                          <a:solidFill>
+                            <a:schemeClr val="tx1"/>
+                          </a:solidFill>
+                        </a:rPr>
+                        <a:t>0.456</a:t>
+                      </a:r>
+                      <a:endParaRPr lang="en-US" sz="1600" dirty="0"/>
+                    </a:p>
+                  </a:txBody>
+                  <a:tcPr marL="91440" marR="91440" marT="36576" marB="36576" anchor="ctr">
+                    <a:lnL w="9525" cap="flat" cmpd="sng" algn="ctr">
+                      <a:solidFill>
+                        <a:srgbClr val="E1E5EA"/>
+                      </a:solidFill>
+                      <a:prstDash val="solid"/>
+                      <a:round/>
+                      <a:headEnd type="none" w="med" len="med"/>
+                      <a:tailEnd type="none" w="med" len="med"/>
+                    </a:lnL>
+                    <a:lnR w="9525" cap="flat" cmpd="sng" algn="ctr">
+                      <a:solidFill>
+                        <a:srgbClr val="E1E5EA"/>
+                      </a:solidFill>
+                      <a:prstDash val="solid"/>
+                      <a:round/>
+                      <a:headEnd type="none" w="med" len="med"/>
+                      <a:tailEnd type="none" w="med" len="med"/>
+                    </a:lnR>
+                    <a:lnT w="9525" cap="flat" cmpd="sng" algn="ctr">
+                      <a:solidFill>
+                        <a:srgbClr val="E1E5EA"/>
+                      </a:solidFill>
+                      <a:prstDash val="solid"/>
+                      <a:round/>
+                      <a:headEnd type="none" w="med" len="med"/>
+                      <a:tailEnd type="none" w="med" len="med"/>
+                    </a:lnT>
+                    <a:lnB w="9525" cap="flat" cmpd="sng" algn="ctr">
+                      <a:solidFill>
+                        <a:srgbClr val="E1E5EA"/>
+                      </a:solidFill>
+                      <a:prstDash val="solid"/>
+                      <a:round/>
+                      <a:headEnd type="none" w="med" len="med"/>
+                      <a:tailEnd type="none" w="med" len="med"/>
+                    </a:lnB>
+                    <a:solidFill>
+                      <a:srgbClr val="FFFFFF"/>
+                    </a:solidFill>
+                  </a:tcPr>
+                </a:tc>
+              </a:tr>
+              <a:tr h="548640">
+                <a:tc>
+                  <a:txBody>
+                    <a:bodyPr/>
+                    <a:lstStyle/>
+                    <a:p>
+                      <a:pPr algn="l" indent="0" marL="0">
+                        <a:buNone/>
+                      </a:pPr>
+                      <a:r>
+                        <a:rPr lang="en-US" sz="1600" dirty="0">
+                          <a:solidFill>
+                            <a:schemeClr val="tx1"/>
+                          </a:solidFill>
+                        </a:rPr>
+                        <a:t>XLM-R, no class weights</a:t>
+                      </a:r>
+                      <a:endParaRPr lang="en-US" sz="1600" dirty="0"/>
+                    </a:p>
+                  </a:txBody>
+                  <a:tcPr marL="91440" marR="91440" marT="36576" marB="36576" anchor="ctr">
+                    <a:lnL w="9525" cap="flat" cmpd="sng" algn="ctr">
+                      <a:solidFill>
+                        <a:srgbClr val="E1E5EA"/>
+                      </a:solidFill>
+                      <a:prstDash val="solid"/>
+                      <a:round/>
+                      <a:headEnd type="none" w="med" len="med"/>
+                      <a:tailEnd type="none" w="med" len="med"/>
+                    </a:lnL>
+                    <a:lnR w="9525" cap="flat" cmpd="sng" algn="ctr">
+                      <a:solidFill>
+                        <a:srgbClr val="E1E5EA"/>
+                      </a:solidFill>
+                      <a:prstDash val="solid"/>
+                      <a:round/>
+                      <a:headEnd type="none" w="med" len="med"/>
+                      <a:tailEnd type="none" w="med" len="med"/>
+                    </a:lnR>
+                    <a:lnT w="9525" cap="flat" cmpd="sng" algn="ctr">
+                      <a:solidFill>
+                        <a:srgbClr val="E1E5EA"/>
+                      </a:solidFill>
+                      <a:prstDash val="solid"/>
+                      <a:round/>
+                      <a:headEnd type="none" w="med" len="med"/>
+                      <a:tailEnd type="none" w="med" len="med"/>
+                    </a:lnT>
+                    <a:lnB w="9525" cap="flat" cmpd="sng" algn="ctr">
+                      <a:solidFill>
+                        <a:srgbClr val="E1E5EA"/>
+                      </a:solidFill>
+                      <a:prstDash val="solid"/>
+                      <a:round/>
+                      <a:headEnd type="none" w="med" len="med"/>
+                      <a:tailEnd type="none" w="med" len="med"/>
+                    </a:lnB>
+                    <a:solidFill>
+                      <a:srgbClr val="FFFFFF"/>
+                    </a:solidFill>
+                  </a:tcPr>
+                </a:tc>
+                <a:tc>
+                  <a:txBody>
+                    <a:bodyPr/>
+                    <a:lstStyle/>
+                    <a:p>
+                      <a:pPr algn="ctr" indent="0" marL="0">
+                        <a:buNone/>
+                      </a:pPr>
+                      <a:r>
+                        <a:rPr lang="en-US" sz="1600" b="1" dirty="0">
+                          <a:solidFill>
+                            <a:schemeClr val="tx1"/>
+                          </a:solidFill>
+                        </a:rPr>
+                        <a:t>0.772</a:t>
+                      </a:r>
+                      <a:endParaRPr lang="en-US" sz="1600" dirty="0"/>
+                    </a:p>
+                  </a:txBody>
+                  <a:tcPr marL="91440" marR="91440" marT="36576" marB="36576" anchor="ctr">
+                    <a:lnL w="9525" cap="flat" cmpd="sng" algn="ctr">
+                      <a:solidFill>
+                        <a:srgbClr val="E1E5EA"/>
+                      </a:solidFill>
+                      <a:prstDash val="solid"/>
+                      <a:round/>
+                      <a:headEnd type="none" w="med" len="med"/>
+                      <a:tailEnd type="none" w="med" len="med"/>
+                    </a:lnL>
+                    <a:lnR w="9525" cap="flat" cmpd="sng" algn="ctr">
+                      <a:solidFill>
+                        <a:srgbClr val="E1E5EA"/>
+                      </a:solidFill>
+                      <a:prstDash val="solid"/>
+                      <a:round/>
+                      <a:headEnd type="none" w="med" len="med"/>
+                      <a:tailEnd type="none" w="med" len="med"/>
+                    </a:lnR>
+                    <a:lnT w="9525" cap="flat" cmpd="sng" algn="ctr">
+                      <a:solidFill>
+                        <a:srgbClr val="E1E5EA"/>
+                      </a:solidFill>
+                      <a:prstDash val="solid"/>
+                      <a:round/>
+                      <a:headEnd type="none" w="med" len="med"/>
+                      <a:tailEnd type="none" w="med" len="med"/>
+                    </a:lnT>
+                    <a:lnB w="9525" cap="flat" cmpd="sng" algn="ctr">
+                      <a:solidFill>
+                        <a:srgbClr val="E1E5EA"/>
+                      </a:solidFill>
+                      <a:prstDash val="solid"/>
+                      <a:round/>
+                      <a:headEnd type="none" w="med" len="med"/>
+                      <a:tailEnd type="none" w="med" len="med"/>
+                    </a:lnB>
+                    <a:solidFill>
+                      <a:srgbClr val="FFFFFF"/>
+                    </a:solidFill>
+                  </a:tcPr>
+                </a:tc>
+                <a:tc>
+                  <a:txBody>
+                    <a:bodyPr/>
+                    <a:lstStyle/>
+                    <a:p>
+                      <a:pPr algn="ctr" indent="0" marL="0">
+                        <a:buNone/>
+                      </a:pPr>
+                      <a:r>
+                        <a:rPr lang="en-US" sz="1600" dirty="0">
+                          <a:solidFill>
+                            <a:schemeClr val="tx1"/>
+                          </a:solidFill>
+                        </a:rPr>
+                        <a:t>0.261</a:t>
+                      </a:r>
+                      <a:endParaRPr lang="en-US" sz="1600" dirty="0"/>
+                    </a:p>
+                  </a:txBody>
+                  <a:tcPr marL="91440" marR="91440" marT="36576" marB="36576" anchor="ctr">
+                    <a:lnL w="9525" cap="flat" cmpd="sng" algn="ctr">
+                      <a:solidFill>
+                        <a:srgbClr val="E1E5EA"/>
+                      </a:solidFill>
+                      <a:prstDash val="solid"/>
+                      <a:round/>
+                      <a:headEnd type="none" w="med" len="med"/>
+                      <a:tailEnd type="none" w="med" len="med"/>
+                    </a:lnL>
+                    <a:lnR w="9525" cap="flat" cmpd="sng" algn="ctr">
+                      <a:solidFill>
+                        <a:srgbClr val="E1E5EA"/>
+                      </a:solidFill>
+                      <a:prstDash val="solid"/>
+                      <a:round/>
+                      <a:headEnd type="none" w="med" len="med"/>
+                      <a:tailEnd type="none" w="med" len="med"/>
+                    </a:lnR>
+                    <a:lnT w="9525" cap="flat" cmpd="sng" algn="ctr">
+                      <a:solidFill>
+                        <a:srgbClr val="E1E5EA"/>
+                      </a:solidFill>
+                      <a:prstDash val="solid"/>
+                      <a:round/>
+                      <a:headEnd type="none" w="med" len="med"/>
+                      <a:tailEnd type="none" w="med" len="med"/>
+                    </a:lnT>
+                    <a:lnB w="9525" cap="flat" cmpd="sng" algn="ctr">
+                      <a:solidFill>
+                        <a:srgbClr val="E1E5EA"/>
+                      </a:solidFill>
+                      <a:prstDash val="solid"/>
+                      <a:round/>
+                      <a:headEnd type="none" w="med" len="med"/>
+                      <a:tailEnd type="none" w="med" len="med"/>
+                    </a:lnB>
+                    <a:solidFill>
+                      <a:srgbClr val="FFFFFF"/>
+                    </a:solidFill>
+                  </a:tcPr>
+                </a:tc>
+                <a:tc>
+                  <a:txBody>
+                    <a:bodyPr/>
+                    <a:lstStyle/>
+                    <a:p>
+                      <a:pPr algn="ctr" indent="0" marL="0">
+                        <a:buNone/>
+                      </a:pPr>
+                      <a:r>
+                        <a:rPr lang="en-US" sz="1600" dirty="0">
+                          <a:solidFill>
+                            <a:schemeClr val="tx1"/>
+                          </a:solidFill>
+                        </a:rPr>
+                        <a:t>0.159</a:t>
+                      </a:r>
+                      <a:endParaRPr lang="en-US" sz="1600" dirty="0"/>
+                    </a:p>
+                  </a:txBody>
+                  <a:tcPr marL="91440" marR="91440" marT="36576" marB="36576" anchor="ctr">
+                    <a:lnL w="9525" cap="flat" cmpd="sng" algn="ctr">
+                      <a:solidFill>
+                        <a:srgbClr val="E1E5EA"/>
+                      </a:solidFill>
+                      <a:prstDash val="solid"/>
+                      <a:round/>
+                      <a:headEnd type="none" w="med" len="med"/>
+                      <a:tailEnd type="none" w="med" len="med"/>
+                    </a:lnL>
+                    <a:lnR w="9525" cap="flat" cmpd="sng" algn="ctr">
+                      <a:solidFill>
+                        <a:srgbClr val="E1E5EA"/>
+                      </a:solidFill>
+                      <a:prstDash val="solid"/>
+                      <a:round/>
+                      <a:headEnd type="none" w="med" len="med"/>
+                      <a:tailEnd type="none" w="med" len="med"/>
+                    </a:lnR>
+                    <a:lnT w="9525" cap="flat" cmpd="sng" algn="ctr">
+                      <a:solidFill>
+                        <a:srgbClr val="E1E5EA"/>
+                      </a:solidFill>
+                      <a:prstDash val="solid"/>
+                      <a:round/>
+                      <a:headEnd type="none" w="med" len="med"/>
+                      <a:tailEnd type="none" w="med" len="med"/>
+                    </a:lnT>
+                    <a:lnB w="9525" cap="flat" cmpd="sng" algn="ctr">
+                      <a:solidFill>
+                        <a:srgbClr val="E1E5EA"/>
+                      </a:solidFill>
+                      <a:prstDash val="solid"/>
+                      <a:round/>
+                      <a:headEnd type="none" w="med" len="med"/>
+                      <a:tailEnd type="none" w="med" len="med"/>
+                    </a:lnB>
+                    <a:solidFill>
+                      <a:srgbClr val="FFFFFF"/>
+                    </a:solidFill>
+                  </a:tcPr>
+                </a:tc>
+              </a:tr>
+              <a:tr h="548640">
+                <a:tc>
+                  <a:txBody>
+                    <a:bodyPr/>
+                    <a:lstStyle/>
+                    <a:p>
+                      <a:pPr algn="l" indent="0" marL="0">
+                        <a:buNone/>
+                      </a:pPr>
+                      <a:r>
+                        <a:rPr lang="en-US" sz="1600" dirty="0">
+                          <a:solidFill>
+                            <a:schemeClr val="tx1"/>
+                          </a:solidFill>
+                        </a:rPr>
+                        <a:t>XLM-R</a:t>
+                      </a:r>
+                      <a:endParaRPr lang="en-US" sz="1600" dirty="0"/>
+                    </a:p>
+                  </a:txBody>
+                  <a:tcPr marL="91440" marR="91440" marT="36576" marB="36576" anchor="ctr">
+                    <a:lnL w="9525" cap="flat" cmpd="sng" algn="ctr">
+                      <a:solidFill>
+                        <a:srgbClr val="E1E5EA"/>
+                      </a:solidFill>
+                      <a:prstDash val="solid"/>
+                      <a:round/>
+                      <a:headEnd type="none" w="med" len="med"/>
+                      <a:tailEnd type="none" w="med" len="med"/>
+                    </a:lnL>
+                    <a:lnR w="9525" cap="flat" cmpd="sng" algn="ctr">
+                      <a:solidFill>
+                        <a:srgbClr val="E1E5EA"/>
+                      </a:solidFill>
+                      <a:prstDash val="solid"/>
+                      <a:round/>
+                      <a:headEnd type="none" w="med" len="med"/>
+                      <a:tailEnd type="none" w="med" len="med"/>
+                    </a:lnR>
+                    <a:lnT w="9525" cap="flat" cmpd="sng" algn="ctr">
+                      <a:solidFill>
+                        <a:srgbClr val="E1E5EA"/>
+                      </a:solidFill>
+                      <a:prstDash val="solid"/>
+                      <a:round/>
+                      <a:headEnd type="none" w="med" len="med"/>
+                      <a:tailEnd type="none" w="med" len="med"/>
+                    </a:lnT>
+                    <a:lnB w="9525" cap="flat" cmpd="sng" algn="ctr">
+                      <a:solidFill>
+                        <a:srgbClr val="E1E5EA"/>
+                      </a:solidFill>
+                      <a:prstDash val="solid"/>
+                      <a:round/>
+                      <a:headEnd type="none" w="med" len="med"/>
+                      <a:tailEnd type="none" w="med" len="med"/>
+                    </a:lnB>
+                    <a:solidFill>
+                      <a:srgbClr val="FFFFFF"/>
+                    </a:solidFill>
+                  </a:tcPr>
+                </a:tc>
+                <a:tc>
+                  <a:txBody>
+                    <a:bodyPr/>
+                    <a:lstStyle/>
+                    <a:p>
+                      <a:pPr algn="ctr" indent="0" marL="0">
+                        <a:buNone/>
+                      </a:pPr>
+                      <a:r>
+                        <a:rPr lang="en-US" sz="1600" dirty="0">
+                          <a:solidFill>
+                            <a:schemeClr val="tx1"/>
+                          </a:solidFill>
+                        </a:rPr>
+                        <a:t>0.769</a:t>
+                      </a:r>
+                      <a:endParaRPr lang="en-US" sz="1600" dirty="0"/>
+                    </a:p>
+                  </a:txBody>
+                  <a:tcPr marL="91440" marR="91440" marT="36576" marB="36576" anchor="ctr">
+                    <a:lnL w="9525" cap="flat" cmpd="sng" algn="ctr">
+                      <a:solidFill>
+                        <a:srgbClr val="E1E5EA"/>
+                      </a:solidFill>
+                      <a:prstDash val="solid"/>
+                      <a:round/>
+                      <a:headEnd type="none" w="med" len="med"/>
+                      <a:tailEnd type="none" w="med" len="med"/>
+                    </a:lnL>
+                    <a:lnR w="9525" cap="flat" cmpd="sng" algn="ctr">
+                      <a:solidFill>
+                        <a:srgbClr val="E1E5EA"/>
+                      </a:solidFill>
+                      <a:prstDash val="solid"/>
+                      <a:round/>
+                      <a:headEnd type="none" w="med" len="med"/>
+                      <a:tailEnd type="none" w="med" len="med"/>
+                    </a:lnR>
+                    <a:lnT w="9525" cap="flat" cmpd="sng" algn="ctr">
+                      <a:solidFill>
+                        <a:srgbClr val="E1E5EA"/>
+                      </a:solidFill>
+                      <a:prstDash val="solid"/>
+                      <a:round/>
+                      <a:headEnd type="none" w="med" len="med"/>
+                      <a:tailEnd type="none" w="med" len="med"/>
+                    </a:lnT>
+                    <a:lnB w="9525" cap="flat" cmpd="sng" algn="ctr">
+                      <a:solidFill>
+                        <a:srgbClr val="E1E5EA"/>
+                      </a:solidFill>
+                      <a:prstDash val="solid"/>
+                      <a:round/>
+                      <a:headEnd type="none" w="med" len="med"/>
+                      <a:tailEnd type="none" w="med" len="med"/>
+                    </a:lnB>
+                    <a:solidFill>
+                      <a:srgbClr val="FFFFFF"/>
+                    </a:solidFill>
+                  </a:tcPr>
+                </a:tc>
+                <a:tc>
+                  <a:txBody>
+                    <a:bodyPr/>
+                    <a:lstStyle/>
+                    <a:p>
+                      <a:pPr algn="ctr" indent="0" marL="0">
+                        <a:buNone/>
+                      </a:pPr>
+                      <a:r>
+                        <a:rPr lang="en-US" sz="1600" dirty="0">
+                          <a:solidFill>
+                            <a:schemeClr val="tx1"/>
+                          </a:solidFill>
+                        </a:rPr>
+                        <a:t>0.556</a:t>
+                      </a:r>
+                      <a:endParaRPr lang="en-US" sz="1600" dirty="0"/>
+                    </a:p>
+                  </a:txBody>
+                  <a:tcPr marL="91440" marR="91440" marT="36576" marB="36576" anchor="ctr">
+                    <a:lnL w="9525" cap="flat" cmpd="sng" algn="ctr">
+                      <a:solidFill>
+                        <a:srgbClr val="E1E5EA"/>
+                      </a:solidFill>
+                      <a:prstDash val="solid"/>
+                      <a:round/>
+                      <a:headEnd type="none" w="med" len="med"/>
+                      <a:tailEnd type="none" w="med" len="med"/>
+                    </a:lnL>
+                    <a:lnR w="9525" cap="flat" cmpd="sng" algn="ctr">
+                      <a:solidFill>
+                        <a:srgbClr val="E1E5EA"/>
+                      </a:solidFill>
+                      <a:prstDash val="solid"/>
+                      <a:round/>
+                      <a:headEnd type="none" w="med" len="med"/>
+                      <a:tailEnd type="none" w="med" len="med"/>
+                    </a:lnR>
+                    <a:lnT w="9525" cap="flat" cmpd="sng" algn="ctr">
+                      <a:solidFill>
+                        <a:srgbClr val="E1E5EA"/>
+                      </a:solidFill>
+                      <a:prstDash val="solid"/>
+                      <a:round/>
+                      <a:headEnd type="none" w="med" len="med"/>
+                      <a:tailEnd type="none" w="med" len="med"/>
+                    </a:lnT>
+                    <a:lnB w="9525" cap="flat" cmpd="sng" algn="ctr">
+                      <a:solidFill>
+                        <a:srgbClr val="E1E5EA"/>
+                      </a:solidFill>
+                      <a:prstDash val="solid"/>
+                      <a:round/>
+                      <a:headEnd type="none" w="med" len="med"/>
+                      <a:tailEnd type="none" w="med" len="med"/>
+                    </a:lnB>
+                    <a:solidFill>
+                      <a:srgbClr val="FFFFFF"/>
+                    </a:solidFill>
+                  </a:tcPr>
+                </a:tc>
+                <a:tc>
+                  <a:txBody>
+                    <a:bodyPr/>
+                    <a:lstStyle/>
+                    <a:p>
+                      <a:pPr algn="ctr" indent="0" marL="0">
+                        <a:buNone/>
+                      </a:pPr>
+                      <a:r>
+                        <a:rPr lang="en-US" sz="1600" dirty="0">
+                          <a:solidFill>
+                            <a:schemeClr val="tx1"/>
+                          </a:solidFill>
+                        </a:rPr>
+                        <a:t>0.449</a:t>
+                      </a:r>
+                      <a:endParaRPr lang="en-US" sz="1600" dirty="0"/>
+                    </a:p>
+                  </a:txBody>
+                  <a:tcPr marL="91440" marR="91440" marT="36576" marB="36576" anchor="ctr">
+                    <a:lnL w="9525" cap="flat" cmpd="sng" algn="ctr">
+                      <a:solidFill>
+                        <a:srgbClr val="E1E5EA"/>
+                      </a:solidFill>
+                      <a:prstDash val="solid"/>
+                      <a:round/>
+                      <a:headEnd type="none" w="med" len="med"/>
+                      <a:tailEnd type="none" w="med" len="med"/>
+                    </a:lnL>
+                    <a:lnR w="9525" cap="flat" cmpd="sng" algn="ctr">
+                      <a:solidFill>
+                        <a:srgbClr val="E1E5EA"/>
+                      </a:solidFill>
+                      <a:prstDash val="solid"/>
+                      <a:round/>
+                      <a:headEnd type="none" w="med" len="med"/>
+                      <a:tailEnd type="none" w="med" len="med"/>
+                    </a:lnR>
+                    <a:lnT w="9525" cap="flat" cmpd="sng" algn="ctr">
+                      <a:solidFill>
+                        <a:srgbClr val="E1E5EA"/>
+                      </a:solidFill>
+                      <a:prstDash val="solid"/>
+                      <a:round/>
+                      <a:headEnd type="none" w="med" len="med"/>
+                      <a:tailEnd type="none" w="med" len="med"/>
+                    </a:lnT>
+                    <a:lnB w="9525" cap="flat" cmpd="sng" algn="ctr">
+                      <a:solidFill>
+                        <a:srgbClr val="E1E5EA"/>
+                      </a:solidFill>
+                      <a:prstDash val="solid"/>
+                      <a:round/>
+                      <a:headEnd type="none" w="med" len="med"/>
+                      <a:tailEnd type="none" w="med" len="med"/>
+                    </a:lnB>
+                    <a:solidFill>
+                      <a:srgbClr val="FFFFFF"/>
+                    </a:solidFill>
+                  </a:tcPr>
+                </a:tc>
+              </a:tr>
+              <a:tr h="548640">
+                <a:tc>
+                  <a:txBody>
+                    <a:bodyPr/>
+                    <a:lstStyle/>
+                    <a:p>
+                      <a:pPr algn="l" indent="0" marL="0">
+                        <a:buNone/>
+                      </a:pPr>
+                      <a:r>
+                        <a:rPr lang="en-US" sz="1600" dirty="0">
+                          <a:solidFill>
+                            <a:schemeClr val="tx1"/>
+                          </a:solidFill>
+                        </a:rPr>
+                        <a:t>mBERT</a:t>
+                      </a:r>
+                      <a:endParaRPr lang="en-US" sz="1600" dirty="0"/>
+                    </a:p>
+                  </a:txBody>
+                  <a:tcPr marL="91440" marR="91440" marT="36576" marB="36576" anchor="ctr">
+                    <a:lnL w="9525" cap="flat" cmpd="sng" algn="ctr">
+                      <a:solidFill>
+                        <a:srgbClr val="E1E5EA"/>
+                      </a:solidFill>
+                      <a:prstDash val="solid"/>
+                      <a:round/>
+                      <a:headEnd type="none" w="med" len="med"/>
+                      <a:tailEnd type="none" w="med" len="med"/>
+                    </a:lnL>
+                    <a:lnR w="9525" cap="flat" cmpd="sng" algn="ctr">
+                      <a:solidFill>
+                        <a:srgbClr val="E1E5EA"/>
+                      </a:solidFill>
+                      <a:prstDash val="solid"/>
+                      <a:round/>
+                      <a:headEnd type="none" w="med" len="med"/>
+                      <a:tailEnd type="none" w="med" len="med"/>
+                    </a:lnR>
+                    <a:lnT w="9525" cap="flat" cmpd="sng" algn="ctr">
+                      <a:solidFill>
+                        <a:srgbClr val="E1E5EA"/>
+                      </a:solidFill>
+                      <a:prstDash val="solid"/>
+                      <a:round/>
+                      <a:headEnd type="none" w="med" len="med"/>
+                      <a:tailEnd type="none" w="med" len="med"/>
+                    </a:lnT>
+                    <a:lnB w="9525" cap="flat" cmpd="sng" algn="ctr">
+                      <a:solidFill>
+                        <a:srgbClr val="E1E5EA"/>
+                      </a:solidFill>
+                      <a:prstDash val="solid"/>
+                      <a:round/>
+                      <a:headEnd type="none" w="med" len="med"/>
+                      <a:tailEnd type="none" w="med" len="med"/>
+                    </a:lnB>
+                    <a:solidFill>
+                      <a:srgbClr val="FFFFFF"/>
+                    </a:solidFill>
+                  </a:tcPr>
+                </a:tc>
+                <a:tc>
+                  <a:txBody>
+                    <a:bodyPr/>
+                    <a:lstStyle/>
+                    <a:p>
+                      <a:pPr algn="ctr" indent="0" marL="0">
+                        <a:buNone/>
+                      </a:pPr>
+                      <a:r>
+                        <a:rPr lang="en-US" sz="1600" dirty="0">
+                          <a:solidFill>
+                            <a:schemeClr val="tx1"/>
+                          </a:solidFill>
+                        </a:rPr>
+                        <a:t>0.760</a:t>
+                      </a:r>
+                      <a:endParaRPr lang="en-US" sz="1600" dirty="0"/>
+                    </a:p>
+                  </a:txBody>
+                  <a:tcPr marL="91440" marR="91440" marT="36576" marB="36576" anchor="ctr">
+                    <a:lnL w="9525" cap="flat" cmpd="sng" algn="ctr">
+                      <a:solidFill>
+                        <a:srgbClr val="E1E5EA"/>
+                      </a:solidFill>
+                      <a:prstDash val="solid"/>
+                      <a:round/>
+                      <a:headEnd type="none" w="med" len="med"/>
+                      <a:tailEnd type="none" w="med" len="med"/>
+                    </a:lnL>
+                    <a:lnR w="9525" cap="flat" cmpd="sng" algn="ctr">
+                      <a:solidFill>
+                        <a:srgbClr val="E1E5EA"/>
+                      </a:solidFill>
+                      <a:prstDash val="solid"/>
+                      <a:round/>
+                      <a:headEnd type="none" w="med" len="med"/>
+                      <a:tailEnd type="none" w="med" len="med"/>
+                    </a:lnR>
+                    <a:lnT w="9525" cap="flat" cmpd="sng" algn="ctr">
+                      <a:solidFill>
+                        <a:srgbClr val="E1E5EA"/>
+                      </a:solidFill>
+                      <a:prstDash val="solid"/>
+                      <a:round/>
+                      <a:headEnd type="none" w="med" len="med"/>
+                      <a:tailEnd type="none" w="med" len="med"/>
+                    </a:lnT>
+                    <a:lnB w="9525" cap="flat" cmpd="sng" algn="ctr">
+                      <a:solidFill>
+                        <a:srgbClr val="E1E5EA"/>
+                      </a:solidFill>
+                      <a:prstDash val="solid"/>
+                      <a:round/>
+                      <a:headEnd type="none" w="med" len="med"/>
+                      <a:tailEnd type="none" w="med" len="med"/>
+                    </a:lnB>
+                    <a:solidFill>
+                      <a:srgbClr val="FFFFFF"/>
+                    </a:solidFill>
+                  </a:tcPr>
+                </a:tc>
+                <a:tc>
+                  <a:txBody>
+                    <a:bodyPr/>
+                    <a:lstStyle/>
+                    <a:p>
+                      <a:pPr algn="ctr" indent="0" marL="0">
+                        <a:buNone/>
+                      </a:pPr>
+                      <a:r>
+                        <a:rPr lang="en-US" sz="1600" dirty="0">
+                          <a:solidFill>
+                            <a:schemeClr val="tx1"/>
+                          </a:solidFill>
+                        </a:rPr>
+                        <a:t>0.565</a:t>
+                      </a:r>
+                      <a:endParaRPr lang="en-US" sz="1600" dirty="0"/>
+                    </a:p>
+                  </a:txBody>
+                  <a:tcPr marL="91440" marR="91440" marT="36576" marB="36576" anchor="ctr">
+                    <a:lnL w="9525" cap="flat" cmpd="sng" algn="ctr">
+                      <a:solidFill>
+                        <a:srgbClr val="E1E5EA"/>
+                      </a:solidFill>
+                      <a:prstDash val="solid"/>
+                      <a:round/>
+                      <a:headEnd type="none" w="med" len="med"/>
+                      <a:tailEnd type="none" w="med" len="med"/>
+                    </a:lnL>
+                    <a:lnR w="9525" cap="flat" cmpd="sng" algn="ctr">
+                      <a:solidFill>
+                        <a:srgbClr val="E1E5EA"/>
+                      </a:solidFill>
+                      <a:prstDash val="solid"/>
+                      <a:round/>
+                      <a:headEnd type="none" w="med" len="med"/>
+                      <a:tailEnd type="none" w="med" len="med"/>
+                    </a:lnR>
+                    <a:lnT w="9525" cap="flat" cmpd="sng" algn="ctr">
+                      <a:solidFill>
+                        <a:srgbClr val="E1E5EA"/>
+                      </a:solidFill>
+                      <a:prstDash val="solid"/>
+                      <a:round/>
+                      <a:headEnd type="none" w="med" len="med"/>
+                      <a:tailEnd type="none" w="med" len="med"/>
+                    </a:lnT>
+                    <a:lnB w="9525" cap="flat" cmpd="sng" algn="ctr">
+                      <a:solidFill>
+                        <a:srgbClr val="E1E5EA"/>
+                      </a:solidFill>
+                      <a:prstDash val="solid"/>
+                      <a:round/>
+                      <a:headEnd type="none" w="med" len="med"/>
+                      <a:tailEnd type="none" w="med" len="med"/>
+                    </a:lnB>
+                    <a:solidFill>
+                      <a:srgbClr val="FFFFFF"/>
+                    </a:solidFill>
+                  </a:tcPr>
+                </a:tc>
+                <a:tc>
+                  <a:txBody>
+                    <a:bodyPr/>
+                    <a:lstStyle/>
+                    <a:p>
+                      <a:pPr algn="ctr" indent="0" marL="0">
+                        <a:buNone/>
+                      </a:pPr>
+                      <a:r>
+                        <a:rPr lang="en-US" sz="1600" dirty="0">
+                          <a:solidFill>
+                            <a:schemeClr val="tx1"/>
+                          </a:solidFill>
+                        </a:rPr>
+                        <a:t>0.448</a:t>
+                      </a:r>
+                      <a:endParaRPr lang="en-US" sz="1600" dirty="0"/>
+                    </a:p>
+                  </a:txBody>
+                  <a:tcPr marL="91440" marR="91440" marT="36576" marB="36576" anchor="ctr">
+                    <a:lnL w="9525" cap="flat" cmpd="sng" algn="ctr">
+                      <a:solidFill>
+                        <a:srgbClr val="E1E5EA"/>
+                      </a:solidFill>
+                      <a:prstDash val="solid"/>
+                      <a:round/>
+                      <a:headEnd type="none" w="med" len="med"/>
+                      <a:tailEnd type="none" w="med" len="med"/>
+                    </a:lnL>
+                    <a:lnR w="9525" cap="flat" cmpd="sng" algn="ctr">
+                      <a:solidFill>
+                        <a:srgbClr val="E1E5EA"/>
+                      </a:solidFill>
+                      <a:prstDash val="solid"/>
+                      <a:round/>
+                      <a:headEnd type="none" w="med" len="med"/>
+                      <a:tailEnd type="none" w="med" len="med"/>
+                    </a:lnR>
+                    <a:lnT w="9525" cap="flat" cmpd="sng" algn="ctr">
+                      <a:solidFill>
+                        <a:srgbClr val="E1E5EA"/>
+                      </a:solidFill>
+                      <a:prstDash val="solid"/>
+                      <a:round/>
+                      <a:headEnd type="none" w="med" len="med"/>
+                      <a:tailEnd type="none" w="med" len="med"/>
+                    </a:lnT>
+                    <a:lnB w="9525" cap="flat" cmpd="sng" algn="ctr">
+                      <a:solidFill>
+                        <a:srgbClr val="E1E5EA"/>
+                      </a:solidFill>
+                      <a:prstDash val="solid"/>
+                      <a:round/>
+                      <a:headEnd type="none" w="med" len="med"/>
+                      <a:tailEnd type="none" w="med" len="med"/>
+                    </a:lnB>
+                    <a:solidFill>
+                      <a:srgbClr val="FFFFFF"/>
+                    </a:solidFill>
+                  </a:tcPr>
+                </a:tc>
+              </a:tr>
+              <a:tr h="548640">
+                <a:tc>
+                  <a:txBody>
+                    <a:bodyPr/>
+                    <a:lstStyle/>
+                    <a:p>
+                      <a:pPr algn="l" indent="0" marL="0">
+                        <a:buNone/>
+                      </a:pPr>
+                      <a:r>
+                        <a:rPr lang="en-US" sz="1600" dirty="0">
+                          <a:solidFill>
+                            <a:schemeClr val="tx1"/>
+                          </a:solidFill>
+                        </a:rPr>
+                        <a:t>Bi-LSTM, words</a:t>
+                      </a:r>
+                      <a:endParaRPr lang="en-US" sz="1600" dirty="0"/>
+                    </a:p>
+                  </a:txBody>
+                  <a:tcPr marL="91440" marR="91440" marT="36576" marB="36576" anchor="ctr">
+                    <a:lnL w="9525" cap="flat" cmpd="sng" algn="ctr">
+                      <a:solidFill>
+                        <a:srgbClr val="E1E5EA"/>
+                      </a:solidFill>
+                      <a:prstDash val="solid"/>
+                      <a:round/>
+                      <a:headEnd type="none" w="med" len="med"/>
+                      <a:tailEnd type="none" w="med" len="med"/>
+                    </a:lnL>
+                    <a:lnR w="9525" cap="flat" cmpd="sng" algn="ctr">
+                      <a:solidFill>
+                        <a:srgbClr val="E1E5EA"/>
+                      </a:solidFill>
+                      <a:prstDash val="solid"/>
+                      <a:round/>
+                      <a:headEnd type="none" w="med" len="med"/>
+                      <a:tailEnd type="none" w="med" len="med"/>
+                    </a:lnR>
+                    <a:lnT w="9525" cap="flat" cmpd="sng" algn="ctr">
+                      <a:solidFill>
+                        <a:srgbClr val="E1E5EA"/>
+                      </a:solidFill>
+                      <a:prstDash val="solid"/>
+                      <a:round/>
+                      <a:headEnd type="none" w="med" len="med"/>
+                      <a:tailEnd type="none" w="med" len="med"/>
+                    </a:lnT>
+                    <a:lnB w="9525" cap="flat" cmpd="sng" algn="ctr">
+                      <a:solidFill>
+                        <a:srgbClr val="E1E5EA"/>
+                      </a:solidFill>
+                      <a:prstDash val="solid"/>
+                      <a:round/>
+                      <a:headEnd type="none" w="med" len="med"/>
+                      <a:tailEnd type="none" w="med" len="med"/>
+                    </a:lnB>
+                    <a:solidFill>
+                      <a:srgbClr val="FFFFFF"/>
+                    </a:solidFill>
+                  </a:tcPr>
+                </a:tc>
+                <a:tc>
+                  <a:txBody>
+                    <a:bodyPr/>
+                    <a:lstStyle/>
+                    <a:p>
+                      <a:pPr algn="ctr" indent="0" marL="0">
+                        <a:buNone/>
+                      </a:pPr>
+                      <a:r>
+                        <a:rPr lang="en-US" sz="1600" dirty="0">
+                          <a:solidFill>
+                            <a:schemeClr val="tx1"/>
+                          </a:solidFill>
+                        </a:rPr>
+                        <a:t>0.686</a:t>
+                      </a:r>
+                      <a:endParaRPr lang="en-US" sz="1600" dirty="0"/>
+                    </a:p>
+                  </a:txBody>
+                  <a:tcPr marL="91440" marR="91440" marT="36576" marB="36576" anchor="ctr">
+                    <a:lnL w="9525" cap="flat" cmpd="sng" algn="ctr">
+                      <a:solidFill>
+                        <a:srgbClr val="E1E5EA"/>
+                      </a:solidFill>
+                      <a:prstDash val="solid"/>
+                      <a:round/>
+                      <a:headEnd type="none" w="med" len="med"/>
+                      <a:tailEnd type="none" w="med" len="med"/>
+                    </a:lnL>
+                    <a:lnR w="9525" cap="flat" cmpd="sng" algn="ctr">
+                      <a:solidFill>
+                        <a:srgbClr val="E1E5EA"/>
+                      </a:solidFill>
+                      <a:prstDash val="solid"/>
+                      <a:round/>
+                      <a:headEnd type="none" w="med" len="med"/>
+                      <a:tailEnd type="none" w="med" len="med"/>
+                    </a:lnR>
+                    <a:lnT w="9525" cap="flat" cmpd="sng" algn="ctr">
+                      <a:solidFill>
+                        <a:srgbClr val="E1E5EA"/>
+                      </a:solidFill>
+                      <a:prstDash val="solid"/>
+                      <a:round/>
+                      <a:headEnd type="none" w="med" len="med"/>
+                      <a:tailEnd type="none" w="med" len="med"/>
+                    </a:lnT>
+                    <a:lnB w="9525" cap="flat" cmpd="sng" algn="ctr">
+                      <a:solidFill>
+                        <a:srgbClr val="E1E5EA"/>
+                      </a:solidFill>
+                      <a:prstDash val="solid"/>
+                      <a:round/>
+                      <a:headEnd type="none" w="med" len="med"/>
+                      <a:tailEnd type="none" w="med" len="med"/>
+                    </a:lnB>
+                    <a:solidFill>
+                      <a:srgbClr val="FFFFFF"/>
+                    </a:solidFill>
+                  </a:tcPr>
+                </a:tc>
+                <a:tc>
+                  <a:txBody>
+                    <a:bodyPr/>
+                    <a:lstStyle/>
+                    <a:p>
+                      <a:pPr algn="ctr" indent="0" marL="0">
+                        <a:buNone/>
+                      </a:pPr>
+                      <a:r>
+                        <a:rPr lang="en-US" sz="1600" dirty="0">
+                          <a:solidFill>
+                            <a:schemeClr val="tx1"/>
+                          </a:solidFill>
+                        </a:rPr>
+                        <a:t>0.481</a:t>
+                      </a:r>
+                      <a:endParaRPr lang="en-US" sz="1600" dirty="0"/>
+                    </a:p>
+                  </a:txBody>
+                  <a:tcPr marL="91440" marR="91440" marT="36576" marB="36576" anchor="ctr">
+                    <a:lnL w="9525" cap="flat" cmpd="sng" algn="ctr">
+                      <a:solidFill>
+                        <a:srgbClr val="E1E5EA"/>
+                      </a:solidFill>
+                      <a:prstDash val="solid"/>
+                      <a:round/>
+                      <a:headEnd type="none" w="med" len="med"/>
+                      <a:tailEnd type="none" w="med" len="med"/>
+                    </a:lnL>
+                    <a:lnR w="9525" cap="flat" cmpd="sng" algn="ctr">
+                      <a:solidFill>
+                        <a:srgbClr val="E1E5EA"/>
+                      </a:solidFill>
+                      <a:prstDash val="solid"/>
+                      <a:round/>
+                      <a:headEnd type="none" w="med" len="med"/>
+                      <a:tailEnd type="none" w="med" len="med"/>
+                    </a:lnR>
+                    <a:lnT w="9525" cap="flat" cmpd="sng" algn="ctr">
+                      <a:solidFill>
+                        <a:srgbClr val="E1E5EA"/>
+                      </a:solidFill>
+                      <a:prstDash val="solid"/>
+                      <a:round/>
+                      <a:headEnd type="none" w="med" len="med"/>
+                      <a:tailEnd type="none" w="med" len="med"/>
+                    </a:lnT>
+                    <a:lnB w="9525" cap="flat" cmpd="sng" algn="ctr">
+                      <a:solidFill>
+                        <a:srgbClr val="E1E5EA"/>
+                      </a:solidFill>
+                      <a:prstDash val="solid"/>
+                      <a:round/>
+                      <a:headEnd type="none" w="med" len="med"/>
+                      <a:tailEnd type="none" w="med" len="med"/>
+                    </a:lnB>
+                    <a:solidFill>
+                      <a:srgbClr val="FFFFFF"/>
+                    </a:solidFill>
+                  </a:tcPr>
+                </a:tc>
+                <a:tc>
+                  <a:txBody>
+                    <a:bodyPr/>
+                    <a:lstStyle/>
+                    <a:p>
+                      <a:pPr algn="ctr" indent="0" marL="0">
+                        <a:buNone/>
+                      </a:pPr>
+                      <a:r>
+                        <a:rPr lang="en-US" sz="1600" dirty="0">
+                          <a:solidFill>
+                            <a:schemeClr val="tx1"/>
+                          </a:solidFill>
+                        </a:rPr>
+                        <a:t>0.392</a:t>
+                      </a:r>
+                      <a:endParaRPr lang="en-US" sz="1600" dirty="0"/>
+                    </a:p>
+                  </a:txBody>
+                  <a:tcPr marL="91440" marR="91440" marT="36576" marB="36576" anchor="ctr">
+                    <a:lnL w="9525" cap="flat" cmpd="sng" algn="ctr">
+                      <a:solidFill>
+                        <a:srgbClr val="E1E5EA"/>
+                      </a:solidFill>
+                      <a:prstDash val="solid"/>
+                      <a:round/>
+                      <a:headEnd type="none" w="med" len="med"/>
+                      <a:tailEnd type="none" w="med" len="med"/>
+                    </a:lnL>
+                    <a:lnR w="9525" cap="flat" cmpd="sng" algn="ctr">
+                      <a:solidFill>
+                        <a:srgbClr val="E1E5EA"/>
+                      </a:solidFill>
+                      <a:prstDash val="solid"/>
+                      <a:round/>
+                      <a:headEnd type="none" w="med" len="med"/>
+                      <a:tailEnd type="none" w="med" len="med"/>
+                    </a:lnR>
+                    <a:lnT w="9525" cap="flat" cmpd="sng" algn="ctr">
+                      <a:solidFill>
+                        <a:srgbClr val="E1E5EA"/>
+                      </a:solidFill>
+                      <a:prstDash val="solid"/>
+                      <a:round/>
+                      <a:headEnd type="none" w="med" len="med"/>
+                      <a:tailEnd type="none" w="med" len="med"/>
+                    </a:lnT>
+                    <a:lnB w="9525" cap="flat" cmpd="sng" algn="ctr">
+                      <a:solidFill>
+                        <a:srgbClr val="E1E5EA"/>
+                      </a:solidFill>
+                      <a:prstDash val="solid"/>
+                      <a:round/>
+                      <a:headEnd type="none" w="med" len="med"/>
+                      <a:tailEnd type="none" w="med" len="med"/>
+                    </a:lnB>
+                    <a:solidFill>
+                      <a:srgbClr val="FFFFFF"/>
+                    </a:solidFill>
+                  </a:tcPr>
+                </a:tc>
+              </a:tr>
+              <a:tr h="548640">
+                <a:tc>
+                  <a:txBody>
+                    <a:bodyPr/>
+                    <a:lstStyle/>
+                    <a:p>
+                      <a:pPr algn="l" indent="0" marL="0">
+                        <a:buNone/>
+                      </a:pPr>
+                      <a:r>
+                        <a:rPr lang="en-US" sz="1600" dirty="0">
+                          <a:solidFill>
+                            <a:schemeClr val="tx1"/>
+                          </a:solidFill>
+                        </a:rPr>
+                        <a:t>Bi-LSTM, syllables</a:t>
+                      </a:r>
+                      <a:endParaRPr lang="en-US" sz="1600" dirty="0"/>
+                    </a:p>
+                  </a:txBody>
+                  <a:tcPr marL="91440" marR="91440" marT="36576" marB="36576" anchor="ctr">
+                    <a:lnL w="9525" cap="flat" cmpd="sng" algn="ctr">
+                      <a:solidFill>
+                        <a:srgbClr val="E1E5EA"/>
+                      </a:solidFill>
+                      <a:prstDash val="solid"/>
+                      <a:round/>
+                      <a:headEnd type="none" w="med" len="med"/>
+                      <a:tailEnd type="none" w="med" len="med"/>
+                    </a:lnL>
+                    <a:lnR w="9525" cap="flat" cmpd="sng" algn="ctr">
+                      <a:solidFill>
+                        <a:srgbClr val="E1E5EA"/>
+                      </a:solidFill>
+                      <a:prstDash val="solid"/>
+                      <a:round/>
+                      <a:headEnd type="none" w="med" len="med"/>
+                      <a:tailEnd type="none" w="med" len="med"/>
+                    </a:lnR>
+                    <a:lnT w="9525" cap="flat" cmpd="sng" algn="ctr">
+                      <a:solidFill>
+                        <a:srgbClr val="E1E5EA"/>
+                      </a:solidFill>
+                      <a:prstDash val="solid"/>
+                      <a:round/>
+                      <a:headEnd type="none" w="med" len="med"/>
+                      <a:tailEnd type="none" w="med" len="med"/>
+                    </a:lnT>
+                    <a:lnB w="9525" cap="flat" cmpd="sng" algn="ctr">
+                      <a:solidFill>
+                        <a:srgbClr val="E1E5EA"/>
+                      </a:solidFill>
+                      <a:prstDash val="solid"/>
+                      <a:round/>
+                      <a:headEnd type="none" w="med" len="med"/>
+                      <a:tailEnd type="none" w="med" len="med"/>
+                    </a:lnB>
+                    <a:solidFill>
+                      <a:srgbClr val="FFFFFF"/>
+                    </a:solidFill>
+                  </a:tcPr>
+                </a:tc>
+                <a:tc>
+                  <a:txBody>
+                    <a:bodyPr/>
+                    <a:lstStyle/>
+                    <a:p>
+                      <a:pPr algn="ctr" indent="0" marL="0">
+                        <a:buNone/>
+                      </a:pPr>
+                      <a:r>
+                        <a:rPr lang="en-US" sz="1600" dirty="0">
+                          <a:solidFill>
+                            <a:schemeClr val="tx1"/>
+                          </a:solidFill>
+                        </a:rPr>
+                        <a:t>0.734</a:t>
+                      </a:r>
+                      <a:endParaRPr lang="en-US" sz="1600" dirty="0"/>
+                    </a:p>
+                  </a:txBody>
+                  <a:tcPr marL="91440" marR="91440" marT="36576" marB="36576" anchor="ctr">
+                    <a:lnL w="9525" cap="flat" cmpd="sng" algn="ctr">
+                      <a:solidFill>
+                        <a:srgbClr val="E1E5EA"/>
+                      </a:solidFill>
+                      <a:prstDash val="solid"/>
+                      <a:round/>
+                      <a:headEnd type="none" w="med" len="med"/>
+                      <a:tailEnd type="none" w="med" len="med"/>
+                    </a:lnL>
+                    <a:lnR w="9525" cap="flat" cmpd="sng" algn="ctr">
+                      <a:solidFill>
+                        <a:srgbClr val="E1E5EA"/>
+                      </a:solidFill>
+                      <a:prstDash val="solid"/>
+                      <a:round/>
+                      <a:headEnd type="none" w="med" len="med"/>
+                      <a:tailEnd type="none" w="med" len="med"/>
+                    </a:lnR>
+                    <a:lnT w="9525" cap="flat" cmpd="sng" algn="ctr">
+                      <a:solidFill>
+                        <a:srgbClr val="E1E5EA"/>
+                      </a:solidFill>
+                      <a:prstDash val="solid"/>
+                      <a:round/>
+                      <a:headEnd type="none" w="med" len="med"/>
+                      <a:tailEnd type="none" w="med" len="med"/>
+                    </a:lnT>
+                    <a:lnB w="9525" cap="flat" cmpd="sng" algn="ctr">
+                      <a:solidFill>
+                        <a:srgbClr val="E1E5EA"/>
+                      </a:solidFill>
+                      <a:prstDash val="solid"/>
+                      <a:round/>
+                      <a:headEnd type="none" w="med" len="med"/>
+                      <a:tailEnd type="none" w="med" len="med"/>
+                    </a:lnB>
+                    <a:solidFill>
+                      <a:srgbClr val="FFFFFF"/>
+                    </a:solidFill>
+                  </a:tcPr>
+                </a:tc>
+                <a:tc>
+                  <a:txBody>
+                    <a:bodyPr/>
+                    <a:lstStyle/>
+                    <a:p>
+                      <a:pPr algn="ctr" indent="0" marL="0">
+                        <a:buNone/>
+                      </a:pPr>
+                      <a:r>
+                        <a:rPr lang="en-US" sz="1600" b="1" dirty="0">
+                          <a:solidFill>
+                            <a:schemeClr val="tx1"/>
+                          </a:solidFill>
+                        </a:rPr>
+                        <a:t>0.604</a:t>
+                      </a:r>
+                      <a:endParaRPr lang="en-US" sz="1600" dirty="0"/>
+                    </a:p>
+                  </a:txBody>
+                  <a:tcPr marL="91440" marR="91440" marT="36576" marB="36576" anchor="ctr">
+                    <a:lnL w="9525" cap="flat" cmpd="sng" algn="ctr">
+                      <a:solidFill>
+                        <a:srgbClr val="E1E5EA"/>
+                      </a:solidFill>
+                      <a:prstDash val="solid"/>
+                      <a:round/>
+                      <a:headEnd type="none" w="med" len="med"/>
+                      <a:tailEnd type="none" w="med" len="med"/>
+                    </a:lnL>
+                    <a:lnR w="9525" cap="flat" cmpd="sng" algn="ctr">
+                      <a:solidFill>
+                        <a:srgbClr val="E1E5EA"/>
+                      </a:solidFill>
+                      <a:prstDash val="solid"/>
+                      <a:round/>
+                      <a:headEnd type="none" w="med" len="med"/>
+                      <a:tailEnd type="none" w="med" len="med"/>
+                    </a:lnR>
+                    <a:lnT w="9525" cap="flat" cmpd="sng" algn="ctr">
+                      <a:solidFill>
+                        <a:srgbClr val="E1E5EA"/>
+                      </a:solidFill>
+                      <a:prstDash val="solid"/>
+                      <a:round/>
+                      <a:headEnd type="none" w="med" len="med"/>
+                      <a:tailEnd type="none" w="med" len="med"/>
+                    </a:lnT>
+                    <a:lnB w="9525" cap="flat" cmpd="sng" algn="ctr">
+                      <a:solidFill>
+                        <a:srgbClr val="E1E5EA"/>
+                      </a:solidFill>
+                      <a:prstDash val="solid"/>
+                      <a:round/>
+                      <a:headEnd type="none" w="med" len="med"/>
+                      <a:tailEnd type="none" w="med" len="med"/>
+                    </a:lnB>
+                    <a:solidFill>
+                      <a:srgbClr val="FFFFFF"/>
+                    </a:solidFill>
+                  </a:tcPr>
+                </a:tc>
+                <a:tc>
+                  <a:txBody>
+                    <a:bodyPr/>
+                    <a:lstStyle/>
+                    <a:p>
+                      <a:pPr algn="ctr" indent="0" marL="0">
+                        <a:buNone/>
+                      </a:pPr>
+                      <a:r>
+                        <a:rPr lang="en-US" sz="1600" b="1" dirty="0">
+                          <a:solidFill>
+                            <a:schemeClr val="tx1"/>
+                          </a:solidFill>
+                        </a:rPr>
+                        <a:t>0.461</a:t>
+                      </a:r>
+                      <a:endParaRPr lang="en-US" sz="1600" dirty="0"/>
+                    </a:p>
+                  </a:txBody>
+                  <a:tcPr marL="91440" marR="91440" marT="36576" marB="36576" anchor="ctr">
+                    <a:lnL w="9525" cap="flat" cmpd="sng" algn="ctr">
+                      <a:solidFill>
+                        <a:srgbClr val="E1E5EA"/>
+                      </a:solidFill>
+                      <a:prstDash val="solid"/>
+                      <a:round/>
+                      <a:headEnd type="none" w="med" len="med"/>
+                      <a:tailEnd type="none" w="med" len="med"/>
+                    </a:lnL>
+                    <a:lnR w="9525" cap="flat" cmpd="sng" algn="ctr">
+                      <a:solidFill>
+                        <a:srgbClr val="E1E5EA"/>
+                      </a:solidFill>
+                      <a:prstDash val="solid"/>
+                      <a:round/>
+                      <a:headEnd type="none" w="med" len="med"/>
+                      <a:tailEnd type="none" w="med" len="med"/>
+                    </a:lnR>
+                    <a:lnT w="9525" cap="flat" cmpd="sng" algn="ctr">
+                      <a:solidFill>
+                        <a:srgbClr val="E1E5EA"/>
+                      </a:solidFill>
+                      <a:prstDash val="solid"/>
+                      <a:round/>
+                      <a:headEnd type="none" w="med" len="med"/>
+                      <a:tailEnd type="none" w="med" len="med"/>
+                    </a:lnT>
+                    <a:lnB w="9525" cap="flat" cmpd="sng" algn="ctr">
+                      <a:solidFill>
+                        <a:srgbClr val="E1E5EA"/>
+                      </a:solidFill>
+                      <a:prstDash val="solid"/>
+                      <a:round/>
+                      <a:headEnd type="none" w="med" len="med"/>
+                      <a:tailEnd type="none" w="med" len="med"/>
+                    </a:lnB>
+                    <a:solidFill>
+                      <a:srgbClr val="FFFFFF"/>
+                    </a:solidFill>
+                  </a:tcPr>
+                </a:tc>
+              </a:tr>
+            </a:tbl>
+          </a:graphicData>
+        </a:graphic>
+      </p:graphicFrame>
+      <p:sp>
+        <p:nvSpPr>
+          <p:cNvPr id="6" name="Text 6"/>
+          <p:cNvSpPr txBox="1"/>
+          <p:nvPr/>
+        </p:nvSpPr>
+        <p:spPr>
+          <a:xfrm>
+            <a:off x="640080" y="5394960"/>
+            <a:ext cx="6309360" cy="320040"/>
+          </a:xfrm>
+          <a:prstGeom prst="rect">
+            <a:avLst/>
+          </a:prstGeom>
+          <a:noFill/>
+          <a:ln/>
+        </p:spPr>
+        <p:txBody>
+          <a:bodyPr wrap="square" lIns="0" tIns="0" rIns="0" bIns="0" rtlCol="0" anchor="t"/>
+          <a:lstStyle/>
+          <a:p>
+            <a:pPr indent="0" marL="0">
+              <a:buNone/>
+            </a:pPr>
+            <a:r>
+              <a:rPr lang="en-US" sz="1200" dirty="0">
+                <a:solidFill>
+                  <a:schemeClr val="tx2"/>
+                </a:solidFill>
+              </a:rPr>
+              <a:t>Test macro F1 on his split (1,007 sentences), one run each. Best per column in bold.</a:t>
+            </a:r>
+          </a:p>
+        </p:txBody>
+      </p:sp>
+      <p:sp>
+        <p:nvSpPr>
+          <p:cNvPr id="5" name="Text 5"/>
+          <p:cNvSpPr txBox="1"/>
+          <p:nvPr/>
+        </p:nvSpPr>
+        <p:spPr>
+          <a:xfrm>
+            <a:off x="7315200" y="1417320"/>
+            <a:ext cx="4233672" cy="4846320"/>
+          </a:xfrm>
+          <a:prstGeom prst="rect">
+            <a:avLst/>
+          </a:prstGeom>
+          <a:noFill/>
+          <a:ln/>
+        </p:spPr>
+        <p:txBody>
+          <a:bodyPr wrap="square" lIns="0" tIns="0" rIns="0" bIns="0" rtlCol="0" anchor="t"/>
+          <a:lstStyle/>
+          <a:p>
+            <a:pPr indent="0" marL="0">
+              <a:spcAft>
+                <a:spcPts val="1000"/>
+              </a:spcAft>
+              <a:buNone/>
+            </a:pPr>
+            <a:r>
+              <a:rPr lang="en-US" sz="1600" b="1" dirty="0">
+                <a:solidFill>
+                  <a:schemeClr val="tx1"/>
+                </a:solidFill>
+              </a:rPr>
+              <a:t>XLM-R leads Task 1 </a:t>
+            </a:r>
+            <a:r>
+              <a:rPr lang="en-US" sz="1600" dirty="0">
+                <a:solidFill>
+                  <a:schemeClr val="tx1"/>
+                </a:solidFill>
+              </a:rPr>
+              <a:t>by 0.04; the syllable Bi-LSTM leads Task 2 by 0.02; Task 3 is a tie.</a:t>
+            </a:r>
+            <a:endParaRPr lang="en-US" sz="1600" dirty="0"/>
+          </a:p>
+          <a:p>
+            <a:pPr indent="0" marL="0">
+              <a:spcAft>
+                <a:spcPts val="1000"/>
+              </a:spcAft>
+              <a:buNone/>
+            </a:pPr>
+            <a:r>
+              <a:rPr lang="en-US" sz="1600" b="1" dirty="0">
+                <a:solidFill>
+                  <a:schemeClr val="tx1"/>
+                </a:solidFill>
+              </a:rPr>
+              <a:t>Why the baseline drops (0.790 to 0.733): </a:t>
+            </a:r>
+            <a:r>
+              <a:rPr lang="en-US" sz="1600" dirty="0">
+                <a:solidFill>
+                  <a:schemeClr val="tx1"/>
+                </a:solidFill>
+              </a:rPr>
+              <a:t>the 1,200 rows dropped here were among its easiest (accuracy 0.93).</a:t>
+            </a:r>
+            <a:endParaRPr lang="en-US" sz="1600" dirty="0"/>
+          </a:p>
+          <a:p>
+            <a:pPr indent="0" marL="0">
+              <a:spcAft>
+                <a:spcPts val="1000"/>
+              </a:spcAft>
+              <a:buNone/>
+            </a:pPr>
+            <a:r>
+              <a:rPr lang="en-US" sz="1600" b="1" dirty="0">
+                <a:solidFill>
+                  <a:schemeClr val="tx1"/>
+                </a:solidFill>
+              </a:rPr>
+              <a:t>Class weights are essential: </a:t>
+            </a:r>
+            <a:r>
+              <a:rPr lang="en-US" sz="1600" dirty="0">
+                <a:solidFill>
+                  <a:schemeClr val="tx1"/>
+                </a:solidFill>
+              </a:rPr>
+              <a:t>without them XLM-R scores 0.26 and 0.16 on Tasks 2 and 3.</a:t>
+            </a:r>
+            <a:endParaRPr lang="en-US" sz="1600" dirty="0"/>
+          </a:p>
+          <a:p>
+            <a:pPr indent="0" marL="0">
+              <a:spcAft>
+                <a:spcPts val="1000"/>
+              </a:spcAft>
+              <a:buNone/>
+            </a:pPr>
+            <a:r>
+              <a:rPr lang="en-US" sz="1600" b="1" dirty="0">
+                <a:solidFill>
+                  <a:schemeClr val="tx1"/>
+                </a:solidFill>
+              </a:rPr>
+              <a:t>Syllables beat words again </a:t>
+            </a:r>
+            <a:r>
+              <a:rPr lang="en-US" sz="1600" dirty="0">
+                <a:solidFill>
+                  <a:schemeClr val="tx1"/>
+                </a:solidFill>
+              </a:rPr>
+              <a:t>for the Bi-LSTM, by 0.05 to 0.12.</a:t>
+            </a:r>
+            <a:endParaRPr lang="en-US" sz="1600" dirty="0"/>
+          </a:p>
+          <a:p>
+            <a:pPr indent="0" marL="0">
+              <a:spcAft>
+                <a:spcPts val="1000"/>
+              </a:spcAft>
+              <a:buNone/>
+            </a:pPr>
+            <a:r>
+              <a:rPr lang="en-US" sz="1600" b="1" dirty="0">
+                <a:solidFill>
+                  <a:schemeClr val="tx1"/>
+                </a:solidFill>
+              </a:rPr>
+              <a:t>XLM-R and mBERT </a:t>
+            </a:r>
+            <a:r>
+              <a:rPr lang="en-US" sz="1600" dirty="0">
+                <a:solidFill>
+                  <a:schemeClr val="tx1"/>
+                </a:solidFill>
+              </a:rPr>
+              <a:t>are within 0.01 of each other on every task.</a:t>
+            </a:r>
+            <a:endParaRPr lang="en-US" sz="1600" dirty="0"/>
+          </a:p>
+        </p:txBody>
+      </p:sp>
+      <p:sp>
+        <p:nvSpPr>
+          <p:cNvPr id="25" name="Slide Number Placeholder 0"/>
+          <p:cNvSpPr>
+            <a:spLocks noGrp="1"/>
+          </p:cNvSpPr>
+          <p:nvPr>
+            <p:ph type="sldNum" sz="quarter" idx="4294967295"/>
+          </p:nvPr>
+        </p:nvSpPr>
+        <p:spPr>
+          <a:xfrm>
+            <a:off x="11000232" y="6355080"/>
+            <a:ext cx="548640" cy="274320"/>
+          </a:xfrm>
+          <a:prstGeom prst="rect">
+            <a:avLst/>
+          </a:prstGeom>
+          <a:extLst>
+            <a:ext uri="{C572A759-6A51-4108-AA02-DFA0A04FC94B}">
+              <ma14:wrappingTextBoxFlag xmlns:ma14="http://schemas.microsoft.com/office/mac/drawingml/2011/main" val="0"/>
+            </a:ext>
+          </a:extLst>
+        </p:spPr>
+        <p:txBody>
+          <a:bodyPr/>
+          <a:lstStyle>
+            <a:lvl1pPr>
+              <a:defRPr sz="1100">
+                <a:solidFill>
+                  <a:schemeClr val="tx2"/>
+                </a:solidFill>
+              </a:defRPr>
+            </a:lvl1pPr>
+          </a:lstStyle>
+          <a:p>
+            <a:pPr algn="r"/>
+            <a:fld id="{F7021451-1387-4CA6-816F-3879F97B5CBC}" type="slidenum">
+              <a:rPr b="0" lang="en-US"/>
+              <a:t>10</a:t>
+            </a:fld>
+            <a:endParaRPr lang="en-US"/>
+          </a:p>
+        </p:txBody>
+      </p:sp>
+    </p:spTree>
+  </p:cSld>
+  <p:clrMapOvr>
+    <a:masterClrMapping/>
+  </p:clrMapOvr>
+</p:sld>
+</file>
+
 <file path=ppt/slides/slide2.xml><?xml version="1.0" encoding="utf-8"?>
 <p:sld xmlns:a="http://schemas.openxmlformats.org/drawingml/2006/main" xmlns:r="http://schemas.openxmlformats.org/officeDocument/2006/relationships" xmlns:p="http://schemas.openxmlformats.org/presentationml/2006/main">
   <p:cSld name="Slide 2">
@@ -11412,6 +15128,37 @@
                 </a:solidFill>
               </a:rPr>
               <a:t>as the input unit.</a:t>
+            </a:r>
+            <a:endParaRPr lang="en-US" sz="2000" dirty="0"/>
+          </a:p>
+          <a:p>
+            <a:pPr indent="0" marL="0">
+              <a:spcAft>
+                <a:spcPts val="1000"/>
+              </a:spcAft>
+              <a:buNone/>
+            </a:pPr>
+            <a:r>
+              <a:rPr lang="en-US" sz="2000" b="1" dirty="0">
+                <a:solidFill>
+                  <a:schemeClr val="tx1"/>
+                </a:solidFill>
+              </a:rPr>
+              <a:t>On a second split, </a:t>
+            </a:r>
+            <a:pPr indent="0" marL="0">
+              <a:spcAft>
+                <a:spcPts val="1000"/>
+              </a:spcAft>
+              <a:buNone/>
+            </a:pPr>
+            <a:r>
+              <a:rPr lang="en-US" sz="2000" dirty="0">
+                <a:solidFill>
+                  <a:schemeClr val="tx1"/>
+                </a:solidFill>
+              </a:rPr>
+              <a:t>XLM-R and a syllable Bi-LSTM beat the baseline.</a:t>
             </a:r>
             <a:endParaRPr lang="en-US" sz="2000" dirty="0"/>
           </a:p>

</xml_diff>